<commit_message>
refactor: remove _archive from repo, add strategy comparison to bloque2
- Remove _archive/ directories from git (add to .gitignore)
- Add sampling strategy comparison table to bloque2_ia (A/B/C/D/E)
  with Spearman rho results and guidance on when to use each strategy
</commit_message>
<xml_diff>
--- a/talks/bloque2_ia/csbc26_b2_ia.pptx
+++ b/talks/bloque2_ia/csbc26_b2_ia.pptx
@@ -20,6 +20,8 @@
     <p:sldId id="268" r:id="rId19"/>
     <p:sldId id="269" r:id="rId20"/>
     <p:sldId id="270" r:id="rId21"/>
+    <p:sldId id="271" r:id="rId22"/>
+    <p:sldId id="272" r:id="rId23"/>
   </p:sldIdLst>
   <p:sldSz cx="12188952" cy="6858000" type="screen4x3"/>
   <p:notesSz cx="6858000" cy="9144000"/>
@@ -3358,7 +3360,7 @@
     <p:bg>
       <p:bgPr>
         <a:solidFill>
-          <a:srgbClr val="1A1A2E"/>
+          <a:srgbClr val="0F0F20"/>
         </a:solidFill>
         <a:effectLst/>
       </p:bgPr>
@@ -3378,8 +3380,8 @@
         </p:nvSpPr>
         <p:spPr>
           <a:xfrm>
-            <a:off x="548640" y="1097280"/>
-            <a:ext cx="10515600" cy="27432"/>
+            <a:off x="0" y="0"/>
+            <a:ext cx="12188952" cy="91440"/>
           </a:xfrm>
           <a:prstGeom prst="rect">
             <a:avLst/>
@@ -3421,8 +3423,43 @@
         </p:nvSpPr>
         <p:spPr>
           <a:xfrm>
-            <a:off x="548640" y="320040"/>
-            <a:ext cx="11064240" cy="822960"/>
+            <a:off x="8686800" y="731520"/>
+            <a:ext cx="3200400" cy="4572000"/>
+          </a:xfrm>
+          <a:prstGeom prst="rect">
+            <a:avLst/>
+          </a:prstGeom>
+          <a:noFill/>
+        </p:spPr>
+        <p:txBody>
+          <a:bodyPr wrap="square">
+            <a:spAutoFit/>
+          </a:bodyPr>
+          <a:lstStyle/>
+          <a:p>
+            <a:pPr algn="r"/>
+            <a:r>
+              <a:rPr sz="20000" b="1">
+                <a:solidFill>
+                  <a:srgbClr val="252545"/>
+                </a:solidFill>
+                <a:latin typeface="Calibri"/>
+              </a:rPr>
+              <a:t>3</a:t>
+            </a:r>
+          </a:p>
+        </p:txBody>
+      </p:sp>
+      <p:sp>
+        <p:nvSpPr>
+          <p:cNvPr id="4" name="TextBox 3"/>
+          <p:cNvSpPr txBox="1"/>
+          <p:nvPr/>
+        </p:nvSpPr>
+        <p:spPr>
+          <a:xfrm>
+            <a:off x="548640" y="2011680"/>
+            <a:ext cx="5486400" cy="457200"/>
           </a:xfrm>
           <a:prstGeom prst="rect">
             <a:avLst/>
@@ -3437,40 +3474,75 @@
           <a:p>
             <a:pPr algn="l"/>
             <a:r>
-              <a:rPr sz="3200" b="1">
+              <a:rPr sz="1300" b="1">
+                <a:solidFill>
+                  <a:srgbClr val="E94E4E"/>
+                </a:solidFill>
+                <a:latin typeface="Calibri"/>
+              </a:rPr>
+              <a:t>SECCIÓN</a:t>
+            </a:r>
+          </a:p>
+        </p:txBody>
+      </p:sp>
+      <p:sp>
+        <p:nvSpPr>
+          <p:cNvPr id="5" name="TextBox 4"/>
+          <p:cNvSpPr txBox="1"/>
+          <p:nvPr/>
+        </p:nvSpPr>
+        <p:spPr>
+          <a:xfrm>
+            <a:off x="548640" y="2468880"/>
+            <a:ext cx="8229600" cy="1645920"/>
+          </a:xfrm>
+          <a:prstGeom prst="rect">
+            <a:avLst/>
+          </a:prstGeom>
+          <a:noFill/>
+        </p:spPr>
+        <p:txBody>
+          <a:bodyPr wrap="square">
+            <a:spAutoFit/>
+          </a:bodyPr>
+          <a:lstStyle/>
+          <a:p>
+            <a:pPr algn="l"/>
+            <a:r>
+              <a:rPr sz="4000" b="1">
                 <a:solidFill>
                   <a:srgbClr val="FFFFFF"/>
                 </a:solidFill>
                 <a:latin typeface="Calibri"/>
               </a:rPr>
-              <a:t>NER zero-shot en dominio underground</a:t>
-            </a:r>
-          </a:p>
-        </p:txBody>
-      </p:sp>
-      <p:sp>
-        <p:nvSpPr>
-          <p:cNvPr id="4" name="TextBox 3"/>
-          <p:cNvSpPr txBox="1"/>
-          <p:nvPr/>
-        </p:nvSpPr>
-        <p:spPr>
-          <a:xfrm>
-            <a:off x="548640" y="1371600"/>
-            <a:ext cx="11064240" cy="5029200"/>
-          </a:xfrm>
-          <a:prstGeom prst="rect">
-            <a:avLst/>
-          </a:prstGeom>
-          <a:noFill/>
-        </p:spPr>
-        <p:txBody>
-          <a:bodyPr wrap="square">
-            <a:spAutoFit/>
-          </a:bodyPr>
-          <a:lstStyle/>
-          <a:p>
-            <a:pPr algn="l" marL="0" indent="-228600"/>
+              <a:t>LLMs locales y NER en dominio específico</a:t>
+            </a:r>
+          </a:p>
+        </p:txBody>
+      </p:sp>
+      <p:sp>
+        <p:nvSpPr>
+          <p:cNvPr id="6" name="TextBox 5"/>
+          <p:cNvSpPr txBox="1"/>
+          <p:nvPr/>
+        </p:nvSpPr>
+        <p:spPr>
+          <a:xfrm>
+            <a:off x="548640" y="4206240"/>
+            <a:ext cx="8229600" cy="731520"/>
+          </a:xfrm>
+          <a:prstGeom prst="rect">
+            <a:avLst/>
+          </a:prstGeom>
+          <a:noFill/>
+        </p:spPr>
+        <p:txBody>
+          <a:bodyPr wrap="square">
+            <a:spAutoFit/>
+          </a:bodyPr>
+          <a:lstStyle/>
+          <a:p>
+            <a:pPr algn="l"/>
             <a:r>
               <a:rPr sz="2000" b="0">
                 <a:solidFill>
@@ -3478,67 +3550,7 @@
                 </a:solidFill>
                 <a:latin typeface="Calibri"/>
               </a:rPr>
-              <a:t>▸  NER estándar (spaCy, BERT) falla: no fue entrenado con texto underground</a:t>
-            </a:r>
-          </a:p>
-          <a:p>
-            <a:pPr algn="l" marL="0" indent="-228600"/>
-            <a:r>
-              <a:rPr sz="2000" b="0">
-                <a:solidFill>
-                  <a:srgbClr val="B8C0CC"/>
-                </a:solidFill>
-                <a:latin typeface="Calibri"/>
-              </a:rPr>
-              <a:t>▸  Zero-shot con LLM local: describir el tipo de entidad en el prompt, extraer directamente</a:t>
-            </a:r>
-          </a:p>
-          <a:p>
-            <a:pPr algn="l" marL="0" indent="-228600"/>
-            <a:r>
-              <a:rPr sz="2000" b="0">
-                <a:solidFill>
-                  <a:srgbClr val="B8C0CC"/>
-                </a:solidFill>
-                <a:latin typeface="Calibri"/>
-              </a:rPr>
-              <a:t>▸  Tipos de entidad útiles en este dominio: ALIAS, TOOL, MALWARE, CVE, MARKETPLACE, WALLET</a:t>
-            </a:r>
-          </a:p>
-          <a:p>
-            <a:pPr algn="l" marL="0" indent="-228600"/>
-            <a:r>
-              <a:rPr sz="2000" b="0">
-                <a:solidFill>
-                  <a:srgbClr val="B8C0CC"/>
-                </a:solidFill>
-                <a:latin typeface="Calibri"/>
-              </a:rPr>
-              <a:t>▸  Estrategia: muestra de top-N usuarios × top-M posts más largos + checkpoint automático</a:t>
-            </a:r>
-          </a:p>
-          <a:p>
-            <a:pPr algn="l" marL="0" indent="-228600"/>
-            <a:r>
-              <a:rPr sz="2000" b="0">
-                <a:solidFill>
-                  <a:srgbClr val="B8C0CC"/>
-                </a:solidFill>
-                <a:latin typeface="Calibri"/>
-              </a:rPr>
-              <a:t>▸  Para texto no inglés: el LLM rinde mejor en inglés → traducir el texto primero es aceptable</a:t>
-            </a:r>
-          </a:p>
-          <a:p>
-            <a:pPr algn="l" marL="0" indent="-228600"/>
-            <a:r>
-              <a:rPr sz="2000" b="0">
-                <a:solidFill>
-                  <a:srgbClr val="B8C0CC"/>
-                </a:solidFill>
-                <a:latin typeface="Calibri"/>
-              </a:rPr>
-              <a:t>▸  ¿Por qué es aceptable aquí? Para NER no importa el estilo, solo las entidades</a:t>
+              <a:t>Privacidad no negociable con datos sensibles</a:t>
             </a:r>
           </a:p>
         </p:txBody>
@@ -3642,21 +3654,130 @@
                 </a:solidFill>
                 <a:latin typeface="Calibri"/>
               </a:rPr>
-              <a:t>Idioma original vs. traducción — regla según técnica</a:t>
-            </a:r>
-          </a:p>
-        </p:txBody>
-      </p:sp>
-      <p:sp>
-        <p:nvSpPr>
-          <p:cNvPr id="4" name="Rectangle 3"/>
+              <a:t>La regla es simple: datos sensibles → modelo local</a:t>
+            </a:r>
+          </a:p>
+        </p:txBody>
+      </p:sp>
+      <p:sp>
+        <p:nvSpPr>
+          <p:cNvPr id="4" name="TextBox 3"/>
+          <p:cNvSpPr txBox="1"/>
+          <p:nvPr/>
+        </p:nvSpPr>
+        <p:spPr>
+          <a:xfrm>
+            <a:off x="548640" y="1371600"/>
+            <a:ext cx="11064240" cy="5029200"/>
+          </a:xfrm>
+          <a:prstGeom prst="rect">
+            <a:avLst/>
+          </a:prstGeom>
+          <a:noFill/>
+        </p:spPr>
+        <p:txBody>
+          <a:bodyPr wrap="square">
+            <a:spAutoFit/>
+          </a:bodyPr>
+          <a:lstStyle/>
+          <a:p>
+            <a:pPr algn="l" marL="0" indent="-228600"/>
+            <a:r>
+              <a:rPr sz="2000" b="0">
+                <a:solidFill>
+                  <a:srgbClr val="B8C0CC"/>
+                </a:solidFill>
+                <a:latin typeface="Calibri"/>
+              </a:rPr>
+              <a:t>▸  Nunca se mandan leaks a APIs externas — ni OpenAI, ni Anthropic, ni Google</a:t>
+            </a:r>
+          </a:p>
+          <a:p>
+            <a:pPr algn="l" marL="0" indent="-228600"/>
+            <a:r>
+              <a:rPr sz="2000" b="0">
+                <a:solidFill>
+                  <a:srgbClr val="B8C0CC"/>
+                </a:solidFill>
+                <a:latin typeface="Calibri"/>
+              </a:rPr>
+              <a:t>▸  Ollama: corre modelos cuantizados (Q4/Q8) en hardware modesto sin salida de datos</a:t>
+            </a:r>
+          </a:p>
+          <a:p>
+            <a:pPr algn="l" marL="0" indent="-228600"/>
+            <a:r>
+              <a:rPr sz="2000" b="0">
+                <a:solidFill>
+                  <a:srgbClr val="B8C0CC"/>
+                </a:solidFill>
+                <a:latin typeface="Calibri"/>
+              </a:rPr>
+              <a:t>▸  qwen2.5:14b con Q4 → 16GB RAM, respuestas en segundos, sin nube</a:t>
+            </a:r>
+          </a:p>
+          <a:p>
+            <a:pPr algn="l" marL="0" indent="-228600"/>
+            <a:r>
+              <a:rPr sz="2000" b="0">
+                <a:solidFill>
+                  <a:srgbClr val="B8C0CC"/>
+                </a:solidFill>
+                <a:latin typeface="Calibri"/>
+              </a:rPr>
+              <a:t>▸  El tradeoff: latencia local vs. riesgo de fuga de datos de personas reales</a:t>
+            </a:r>
+          </a:p>
+          <a:p>
+            <a:pPr algn="l" marL="0" indent="-228600"/>
+            <a:r>
+              <a:rPr sz="2000" b="0">
+                <a:solidFill>
+                  <a:srgbClr val="B8C0CC"/>
+                </a:solidFill>
+                <a:latin typeface="Calibri"/>
+              </a:rPr>
+              <a:t>▸  Con datos underground, el riesgo supera siempre al coste de latencia</a:t>
+            </a:r>
+          </a:p>
+        </p:txBody>
+      </p:sp>
+    </p:spTree>
+  </p:cSld>
+  <p:clrMapOvr>
+    <a:masterClrMapping/>
+  </p:clrMapOvr>
+</p:sld>
+</file>
+
+<file path=ppt/slides/slide12.xml><?xml version="1.0" encoding="utf-8"?>
+<p:sld xmlns:a="http://schemas.openxmlformats.org/drawingml/2006/main" xmlns:p="http://schemas.openxmlformats.org/presentationml/2006/main" xmlns:r="http://schemas.openxmlformats.org/officeDocument/2006/relationships">
+  <p:cSld>
+    <p:bg>
+      <p:bgPr>
+        <a:solidFill>
+          <a:srgbClr val="1A1A2E"/>
+        </a:solidFill>
+        <a:effectLst/>
+      </p:bgPr>
+    </p:bg>
+    <p:spTree>
+      <p:nvGrpSpPr>
+        <p:cNvPr id="1" name=""/>
+        <p:cNvGrpSpPr/>
+        <p:nvPr/>
+      </p:nvGrpSpPr>
+      <p:grpSpPr/>
+      <p:sp>
+        <p:nvSpPr>
+          <p:cNvPr id="2" name="Rectangle 1"/>
           <p:cNvSpPr/>
           <p:nvPr/>
         </p:nvSpPr>
         <p:spPr>
           <a:xfrm>
-            <a:off x="548640" y="1325880"/>
-            <a:ext cx="10515600" cy="438912"/>
+            <a:off x="548640" y="1097280"/>
+            <a:ext cx="10515600" cy="27432"/>
           </a:xfrm>
           <a:prstGeom prst="rect">
             <a:avLst/>
@@ -3692,14 +3813,14 @@
       </p:sp>
       <p:sp>
         <p:nvSpPr>
-          <p:cNvPr id="5" name="TextBox 4"/>
-          <p:cNvSpPr txBox="1"/>
-          <p:nvPr/>
-        </p:nvSpPr>
-        <p:spPr>
-          <a:xfrm>
-            <a:off x="594360" y="1385880"/>
-            <a:ext cx="2537460" cy="438912"/>
+          <p:cNvPr id="3" name="TextBox 2"/>
+          <p:cNvSpPr txBox="1"/>
+          <p:nvPr/>
+        </p:nvSpPr>
+        <p:spPr>
+          <a:xfrm>
+            <a:off x="548640" y="320040"/>
+            <a:ext cx="11064240" cy="822960"/>
           </a:xfrm>
           <a:prstGeom prst="rect">
             <a:avLst/>
@@ -3714,954 +3835,13 @@
           <a:p>
             <a:pPr algn="l"/>
             <a:r>
-              <a:rPr sz="1400" b="1">
+              <a:rPr sz="3200" b="1">
                 <a:solidFill>
                   <a:srgbClr val="FFFFFF"/>
                 </a:solidFill>
                 <a:latin typeface="Calibri"/>
               </a:rPr>
-              <a:t>Técnica</a:t>
-            </a:r>
-          </a:p>
-        </p:txBody>
-      </p:sp>
-      <p:sp>
-        <p:nvSpPr>
-          <p:cNvPr id="6" name="TextBox 5"/>
-          <p:cNvSpPr txBox="1"/>
-          <p:nvPr/>
-        </p:nvSpPr>
-        <p:spPr>
-          <a:xfrm>
-            <a:off x="3223260" y="1385880"/>
-            <a:ext cx="2537460" cy="438912"/>
-          </a:xfrm>
-          <a:prstGeom prst="rect">
-            <a:avLst/>
-          </a:prstGeom>
-          <a:noFill/>
-        </p:spPr>
-        <p:txBody>
-          <a:bodyPr wrap="square">
-            <a:spAutoFit/>
-          </a:bodyPr>
-          <a:lstStyle/>
-          <a:p>
-            <a:pPr algn="l"/>
-            <a:r>
-              <a:rPr sz="1400" b="1">
-                <a:solidFill>
-                  <a:srgbClr val="FFFFFF"/>
-                </a:solidFill>
-                <a:latin typeface="Calibri"/>
-              </a:rPr>
-              <a:t>Original</a:t>
-            </a:r>
-          </a:p>
-        </p:txBody>
-      </p:sp>
-      <p:sp>
-        <p:nvSpPr>
-          <p:cNvPr id="7" name="TextBox 6"/>
-          <p:cNvSpPr txBox="1"/>
-          <p:nvPr/>
-        </p:nvSpPr>
-        <p:spPr>
-          <a:xfrm>
-            <a:off x="5852160" y="1385880"/>
-            <a:ext cx="2537460" cy="438912"/>
-          </a:xfrm>
-          <a:prstGeom prst="rect">
-            <a:avLst/>
-          </a:prstGeom>
-          <a:noFill/>
-        </p:spPr>
-        <p:txBody>
-          <a:bodyPr wrap="square">
-            <a:spAutoFit/>
-          </a:bodyPr>
-          <a:lstStyle/>
-          <a:p>
-            <a:pPr algn="l"/>
-            <a:r>
-              <a:rPr sz="1400" b="1">
-                <a:solidFill>
-                  <a:srgbClr val="FFFFFF"/>
-                </a:solidFill>
-                <a:latin typeface="Calibri"/>
-              </a:rPr>
-              <a:t>Traducción</a:t>
-            </a:r>
-          </a:p>
-        </p:txBody>
-      </p:sp>
-      <p:sp>
-        <p:nvSpPr>
-          <p:cNvPr id="8" name="TextBox 7"/>
-          <p:cNvSpPr txBox="1"/>
-          <p:nvPr/>
-        </p:nvSpPr>
-        <p:spPr>
-          <a:xfrm>
-            <a:off x="8481060" y="1385880"/>
-            <a:ext cx="2537460" cy="438912"/>
-          </a:xfrm>
-          <a:prstGeom prst="rect">
-            <a:avLst/>
-          </a:prstGeom>
-          <a:noFill/>
-        </p:spPr>
-        <p:txBody>
-          <a:bodyPr wrap="square">
-            <a:spAutoFit/>
-          </a:bodyPr>
-          <a:lstStyle/>
-          <a:p>
-            <a:pPr algn="l"/>
-            <a:r>
-              <a:rPr sz="1400" b="1">
-                <a:solidFill>
-                  <a:srgbClr val="FFFFFF"/>
-                </a:solidFill>
-                <a:latin typeface="Calibri"/>
-              </a:rPr>
-              <a:t>Por qué</a:t>
-            </a:r>
-          </a:p>
-        </p:txBody>
-      </p:sp>
-      <p:sp>
-        <p:nvSpPr>
-          <p:cNvPr id="9" name="Rectangle 8"/>
-          <p:cNvSpPr/>
-          <p:nvPr/>
-        </p:nvSpPr>
-        <p:spPr>
-          <a:xfrm>
-            <a:off x="548640" y="1764792"/>
-            <a:ext cx="10515600" cy="438912"/>
-          </a:xfrm>
-          <a:prstGeom prst="rect">
-            <a:avLst/>
-          </a:prstGeom>
-          <a:solidFill>
-            <a:srgbClr val="222240"/>
-          </a:solidFill>
-          <a:ln>
-            <a:noFill/>
-          </a:ln>
-        </p:spPr>
-        <p:style>
-          <a:lnRef idx="1">
-            <a:schemeClr val="accent1"/>
-          </a:lnRef>
-          <a:fillRef idx="3">
-            <a:schemeClr val="accent1"/>
-          </a:fillRef>
-          <a:effectRef idx="2">
-            <a:schemeClr val="accent1"/>
-          </a:effectRef>
-          <a:fontRef idx="minor">
-            <a:schemeClr val="lt1"/>
-          </a:fontRef>
-        </p:style>
-        <p:txBody>
-          <a:bodyPr rtlCol="0" anchor="ctr"/>
-          <a:lstStyle/>
-          <a:p>
-            <a:pPr algn="ctr"/>
-          </a:p>
-        </p:txBody>
-      </p:sp>
-      <p:sp>
-        <p:nvSpPr>
-          <p:cNvPr id="10" name="TextBox 9"/>
-          <p:cNvSpPr txBox="1"/>
-          <p:nvPr/>
-        </p:nvSpPr>
-        <p:spPr>
-          <a:xfrm>
-            <a:off x="594360" y="1814792"/>
-            <a:ext cx="2537460" cy="438912"/>
-          </a:xfrm>
-          <a:prstGeom prst="rect">
-            <a:avLst/>
-          </a:prstGeom>
-          <a:noFill/>
-        </p:spPr>
-        <p:txBody>
-          <a:bodyPr wrap="square">
-            <a:spAutoFit/>
-          </a:bodyPr>
-          <a:lstStyle/>
-          <a:p>
-            <a:pPr algn="l"/>
-            <a:r>
-              <a:rPr sz="1300" b="0">
-                <a:solidFill>
-                  <a:srgbClr val="B8C0CC"/>
-                </a:solidFill>
-                <a:latin typeface="Calibri"/>
-              </a:rPr>
-              <a:t>Embeddings</a:t>
-            </a:r>
-          </a:p>
-        </p:txBody>
-      </p:sp>
-      <p:sp>
-        <p:nvSpPr>
-          <p:cNvPr id="11" name="TextBox 10"/>
-          <p:cNvSpPr txBox="1"/>
-          <p:nvPr/>
-        </p:nvSpPr>
-        <p:spPr>
-          <a:xfrm>
-            <a:off x="3223260" y="1814792"/>
-            <a:ext cx="2537460" cy="438912"/>
-          </a:xfrm>
-          <a:prstGeom prst="rect">
-            <a:avLst/>
-          </a:prstGeom>
-          <a:noFill/>
-        </p:spPr>
-        <p:txBody>
-          <a:bodyPr wrap="square">
-            <a:spAutoFit/>
-          </a:bodyPr>
-          <a:lstStyle/>
-          <a:p>
-            <a:pPr algn="l"/>
-            <a:r>
-              <a:rPr sz="1300" b="0">
-                <a:solidFill>
-                  <a:srgbClr val="B8C0CC"/>
-                </a:solidFill>
-                <a:latin typeface="Calibri"/>
-              </a:rPr>
-              <a:t>✓ SIEMPRE</a:t>
-            </a:r>
-          </a:p>
-        </p:txBody>
-      </p:sp>
-      <p:sp>
-        <p:nvSpPr>
-          <p:cNvPr id="12" name="TextBox 11"/>
-          <p:cNvSpPr txBox="1"/>
-          <p:nvPr/>
-        </p:nvSpPr>
-        <p:spPr>
-          <a:xfrm>
-            <a:off x="5852160" y="1814792"/>
-            <a:ext cx="2537460" cy="438912"/>
-          </a:xfrm>
-          <a:prstGeom prst="rect">
-            <a:avLst/>
-          </a:prstGeom>
-          <a:noFill/>
-        </p:spPr>
-        <p:txBody>
-          <a:bodyPr wrap="square">
-            <a:spAutoFit/>
-          </a:bodyPr>
-          <a:lstStyle/>
-          <a:p>
-            <a:pPr algn="l"/>
-            <a:r>
-              <a:rPr sz="1300" b="0">
-                <a:solidFill>
-                  <a:srgbClr val="B8C0CC"/>
-                </a:solidFill>
-                <a:latin typeface="Calibri"/>
-              </a:rPr>
-              <a:t>✗ nunca</a:t>
-            </a:r>
-          </a:p>
-        </p:txBody>
-      </p:sp>
-      <p:sp>
-        <p:nvSpPr>
-          <p:cNvPr id="13" name="TextBox 12"/>
-          <p:cNvSpPr txBox="1"/>
-          <p:nvPr/>
-        </p:nvSpPr>
-        <p:spPr>
-          <a:xfrm>
-            <a:off x="8481060" y="1814792"/>
-            <a:ext cx="2537460" cy="438912"/>
-          </a:xfrm>
-          <a:prstGeom prst="rect">
-            <a:avLst/>
-          </a:prstGeom>
-          <a:noFill/>
-        </p:spPr>
-        <p:txBody>
-          <a:bodyPr wrap="square">
-            <a:spAutoFit/>
-          </a:bodyPr>
-          <a:lstStyle/>
-          <a:p>
-            <a:pPr algn="l"/>
-            <a:r>
-              <a:rPr sz="1300" b="0">
-                <a:solidFill>
-                  <a:srgbClr val="B8C0CC"/>
-                </a:solidFill>
-                <a:latin typeface="Calibri"/>
-              </a:rPr>
-              <a:t>Traducir destruye la huella estilométrica del autor</a:t>
-            </a:r>
-          </a:p>
-        </p:txBody>
-      </p:sp>
-      <p:sp>
-        <p:nvSpPr>
-          <p:cNvPr id="14" name="Rectangle 13"/>
-          <p:cNvSpPr/>
-          <p:nvPr/>
-        </p:nvSpPr>
-        <p:spPr>
-          <a:xfrm>
-            <a:off x="548640" y="2203704"/>
-            <a:ext cx="10515600" cy="438912"/>
-          </a:xfrm>
-          <a:prstGeom prst="rect">
-            <a:avLst/>
-          </a:prstGeom>
-          <a:solidFill>
-            <a:srgbClr val="1E1E38"/>
-          </a:solidFill>
-          <a:ln>
-            <a:noFill/>
-          </a:ln>
-        </p:spPr>
-        <p:style>
-          <a:lnRef idx="1">
-            <a:schemeClr val="accent1"/>
-          </a:lnRef>
-          <a:fillRef idx="3">
-            <a:schemeClr val="accent1"/>
-          </a:fillRef>
-          <a:effectRef idx="2">
-            <a:schemeClr val="accent1"/>
-          </a:effectRef>
-          <a:fontRef idx="minor">
-            <a:schemeClr val="lt1"/>
-          </a:fontRef>
-        </p:style>
-        <p:txBody>
-          <a:bodyPr rtlCol="0" anchor="ctr"/>
-          <a:lstStyle/>
-          <a:p>
-            <a:pPr algn="ctr"/>
-          </a:p>
-        </p:txBody>
-      </p:sp>
-      <p:sp>
-        <p:nvSpPr>
-          <p:cNvPr id="15" name="TextBox 14"/>
-          <p:cNvSpPr txBox="1"/>
-          <p:nvPr/>
-        </p:nvSpPr>
-        <p:spPr>
-          <a:xfrm>
-            <a:off x="594360" y="2253704"/>
-            <a:ext cx="2537460" cy="438912"/>
-          </a:xfrm>
-          <a:prstGeom prst="rect">
-            <a:avLst/>
-          </a:prstGeom>
-          <a:noFill/>
-        </p:spPr>
-        <p:txBody>
-          <a:bodyPr wrap="square">
-            <a:spAutoFit/>
-          </a:bodyPr>
-          <a:lstStyle/>
-          <a:p>
-            <a:pPr algn="l"/>
-            <a:r>
-              <a:rPr sz="1300" b="0">
-                <a:solidFill>
-                  <a:srgbClr val="B8C0CC"/>
-                </a:solidFill>
-                <a:latin typeface="Calibri"/>
-              </a:rPr>
-              <a:t>Estilometría</a:t>
-            </a:r>
-          </a:p>
-        </p:txBody>
-      </p:sp>
-      <p:sp>
-        <p:nvSpPr>
-          <p:cNvPr id="16" name="TextBox 15"/>
-          <p:cNvSpPr txBox="1"/>
-          <p:nvPr/>
-        </p:nvSpPr>
-        <p:spPr>
-          <a:xfrm>
-            <a:off x="3223260" y="2253704"/>
-            <a:ext cx="2537460" cy="438912"/>
-          </a:xfrm>
-          <a:prstGeom prst="rect">
-            <a:avLst/>
-          </a:prstGeom>
-          <a:noFill/>
-        </p:spPr>
-        <p:txBody>
-          <a:bodyPr wrap="square">
-            <a:spAutoFit/>
-          </a:bodyPr>
-          <a:lstStyle/>
-          <a:p>
-            <a:pPr algn="l"/>
-            <a:r>
-              <a:rPr sz="1300" b="0">
-                <a:solidFill>
-                  <a:srgbClr val="B8C0CC"/>
-                </a:solidFill>
-                <a:latin typeface="Calibri"/>
-              </a:rPr>
-              <a:t>✓ SIEMPRE</a:t>
-            </a:r>
-          </a:p>
-        </p:txBody>
-      </p:sp>
-      <p:sp>
-        <p:nvSpPr>
-          <p:cNvPr id="17" name="TextBox 16"/>
-          <p:cNvSpPr txBox="1"/>
-          <p:nvPr/>
-        </p:nvSpPr>
-        <p:spPr>
-          <a:xfrm>
-            <a:off x="5852160" y="2253704"/>
-            <a:ext cx="2537460" cy="438912"/>
-          </a:xfrm>
-          <a:prstGeom prst="rect">
-            <a:avLst/>
-          </a:prstGeom>
-          <a:noFill/>
-        </p:spPr>
-        <p:txBody>
-          <a:bodyPr wrap="square">
-            <a:spAutoFit/>
-          </a:bodyPr>
-          <a:lstStyle/>
-          <a:p>
-            <a:pPr algn="l"/>
-            <a:r>
-              <a:rPr sz="1300" b="0">
-                <a:solidFill>
-                  <a:srgbClr val="B8C0CC"/>
-                </a:solidFill>
-                <a:latin typeface="Calibri"/>
-              </a:rPr>
-              <a:t>✗ nunca</a:t>
-            </a:r>
-          </a:p>
-        </p:txBody>
-      </p:sp>
-      <p:sp>
-        <p:nvSpPr>
-          <p:cNvPr id="18" name="TextBox 17"/>
-          <p:cNvSpPr txBox="1"/>
-          <p:nvPr/>
-        </p:nvSpPr>
-        <p:spPr>
-          <a:xfrm>
-            <a:off x="8481060" y="2253704"/>
-            <a:ext cx="2537460" cy="438912"/>
-          </a:xfrm>
-          <a:prstGeom prst="rect">
-            <a:avLst/>
-          </a:prstGeom>
-          <a:noFill/>
-        </p:spPr>
-        <p:txBody>
-          <a:bodyPr wrap="square">
-            <a:spAutoFit/>
-          </a:bodyPr>
-          <a:lstStyle/>
-          <a:p>
-            <a:pPr algn="l"/>
-            <a:r>
-              <a:rPr sz="1300" b="0">
-                <a:solidFill>
-                  <a:srgbClr val="B8C0CC"/>
-                </a:solidFill>
-                <a:latin typeface="Calibri"/>
-              </a:rPr>
-              <a:t>La señal ES el estilo — no sobrevive la traducción</a:t>
-            </a:r>
-          </a:p>
-        </p:txBody>
-      </p:sp>
-      <p:sp>
-        <p:nvSpPr>
-          <p:cNvPr id="19" name="Rectangle 18"/>
-          <p:cNvSpPr/>
-          <p:nvPr/>
-        </p:nvSpPr>
-        <p:spPr>
-          <a:xfrm>
-            <a:off x="548640" y="2642616"/>
-            <a:ext cx="10515600" cy="438912"/>
-          </a:xfrm>
-          <a:prstGeom prst="rect">
-            <a:avLst/>
-          </a:prstGeom>
-          <a:solidFill>
-            <a:srgbClr val="222240"/>
-          </a:solidFill>
-          <a:ln>
-            <a:noFill/>
-          </a:ln>
-        </p:spPr>
-        <p:style>
-          <a:lnRef idx="1">
-            <a:schemeClr val="accent1"/>
-          </a:lnRef>
-          <a:fillRef idx="3">
-            <a:schemeClr val="accent1"/>
-          </a:fillRef>
-          <a:effectRef idx="2">
-            <a:schemeClr val="accent1"/>
-          </a:effectRef>
-          <a:fontRef idx="minor">
-            <a:schemeClr val="lt1"/>
-          </a:fontRef>
-        </p:style>
-        <p:txBody>
-          <a:bodyPr rtlCol="0" anchor="ctr"/>
-          <a:lstStyle/>
-          <a:p>
-            <a:pPr algn="ctr"/>
-          </a:p>
-        </p:txBody>
-      </p:sp>
-      <p:sp>
-        <p:nvSpPr>
-          <p:cNvPr id="20" name="TextBox 19"/>
-          <p:cNvSpPr txBox="1"/>
-          <p:nvPr/>
-        </p:nvSpPr>
-        <p:spPr>
-          <a:xfrm>
-            <a:off x="594360" y="2692616"/>
-            <a:ext cx="2537460" cy="438912"/>
-          </a:xfrm>
-          <a:prstGeom prst="rect">
-            <a:avLst/>
-          </a:prstGeom>
-          <a:noFill/>
-        </p:spPr>
-        <p:txBody>
-          <a:bodyPr wrap="square">
-            <a:spAutoFit/>
-          </a:bodyPr>
-          <a:lstStyle/>
-          <a:p>
-            <a:pPr algn="l"/>
-            <a:r>
-              <a:rPr sz="1300" b="0">
-                <a:solidFill>
-                  <a:srgbClr val="B8C0CC"/>
-                </a:solidFill>
-                <a:latin typeface="Calibri"/>
-              </a:rPr>
-              <a:t>NER con LLM</a:t>
-            </a:r>
-          </a:p>
-        </p:txBody>
-      </p:sp>
-      <p:sp>
-        <p:nvSpPr>
-          <p:cNvPr id="21" name="TextBox 20"/>
-          <p:cNvSpPr txBox="1"/>
-          <p:nvPr/>
-        </p:nvSpPr>
-        <p:spPr>
-          <a:xfrm>
-            <a:off x="3223260" y="2692616"/>
-            <a:ext cx="2537460" cy="438912"/>
-          </a:xfrm>
-          <a:prstGeom prst="rect">
-            <a:avLst/>
-          </a:prstGeom>
-          <a:noFill/>
-        </p:spPr>
-        <p:txBody>
-          <a:bodyPr wrap="square">
-            <a:spAutoFit/>
-          </a:bodyPr>
-          <a:lstStyle/>
-          <a:p>
-            <a:pPr algn="l"/>
-            <a:r>
-              <a:rPr sz="1300" b="0">
-                <a:solidFill>
-                  <a:srgbClr val="B8C0CC"/>
-                </a:solidFill>
-                <a:latin typeface="Calibri"/>
-              </a:rPr>
-              <a:t>Si el modelo lo soporta bien</a:t>
-            </a:r>
-          </a:p>
-        </p:txBody>
-      </p:sp>
-      <p:sp>
-        <p:nvSpPr>
-          <p:cNvPr id="22" name="TextBox 21"/>
-          <p:cNvSpPr txBox="1"/>
-          <p:nvPr/>
-        </p:nvSpPr>
-        <p:spPr>
-          <a:xfrm>
-            <a:off x="5852160" y="2692616"/>
-            <a:ext cx="2537460" cy="438912"/>
-          </a:xfrm>
-          <a:prstGeom prst="rect">
-            <a:avLst/>
-          </a:prstGeom>
-          <a:noFill/>
-        </p:spPr>
-        <p:txBody>
-          <a:bodyPr wrap="square">
-            <a:spAutoFit/>
-          </a:bodyPr>
-          <a:lstStyle/>
-          <a:p>
-            <a:pPr algn="l"/>
-            <a:r>
-              <a:rPr sz="1300" b="0">
-                <a:solidFill>
-                  <a:srgbClr val="B8C0CC"/>
-                </a:solidFill>
-                <a:latin typeface="Calibri"/>
-              </a:rPr>
-              <a:t>✓ si el modelo base es inglés</a:t>
-            </a:r>
-          </a:p>
-        </p:txBody>
-      </p:sp>
-      <p:sp>
-        <p:nvSpPr>
-          <p:cNvPr id="23" name="TextBox 22"/>
-          <p:cNvSpPr txBox="1"/>
-          <p:nvPr/>
-        </p:nvSpPr>
-        <p:spPr>
-          <a:xfrm>
-            <a:off x="8481060" y="2692616"/>
-            <a:ext cx="2537460" cy="438912"/>
-          </a:xfrm>
-          <a:prstGeom prst="rect">
-            <a:avLst/>
-          </a:prstGeom>
-          <a:noFill/>
-        </p:spPr>
-        <p:txBody>
-          <a:bodyPr wrap="square">
-            <a:spAutoFit/>
-          </a:bodyPr>
-          <a:lstStyle/>
-          <a:p>
-            <a:pPr algn="l"/>
-            <a:r>
-              <a:rPr sz="1300" b="0">
-                <a:solidFill>
-                  <a:srgbClr val="B8C0CC"/>
-                </a:solidFill>
-                <a:latin typeface="Calibri"/>
-              </a:rPr>
-              <a:t>Para NER importa la entidad, no el estilo</a:t>
-            </a:r>
-          </a:p>
-        </p:txBody>
-      </p:sp>
-      <p:sp>
-        <p:nvSpPr>
-          <p:cNvPr id="24" name="Rectangle 23"/>
-          <p:cNvSpPr/>
-          <p:nvPr/>
-        </p:nvSpPr>
-        <p:spPr>
-          <a:xfrm>
-            <a:off x="548640" y="3081528"/>
-            <a:ext cx="10515600" cy="438912"/>
-          </a:xfrm>
-          <a:prstGeom prst="rect">
-            <a:avLst/>
-          </a:prstGeom>
-          <a:solidFill>
-            <a:srgbClr val="1E1E38"/>
-          </a:solidFill>
-          <a:ln>
-            <a:noFill/>
-          </a:ln>
-        </p:spPr>
-        <p:style>
-          <a:lnRef idx="1">
-            <a:schemeClr val="accent1"/>
-          </a:lnRef>
-          <a:fillRef idx="3">
-            <a:schemeClr val="accent1"/>
-          </a:fillRef>
-          <a:effectRef idx="2">
-            <a:schemeClr val="accent1"/>
-          </a:effectRef>
-          <a:fontRef idx="minor">
-            <a:schemeClr val="lt1"/>
-          </a:fontRef>
-        </p:style>
-        <p:txBody>
-          <a:bodyPr rtlCol="0" anchor="ctr"/>
-          <a:lstStyle/>
-          <a:p>
-            <a:pPr algn="ctr"/>
-          </a:p>
-        </p:txBody>
-      </p:sp>
-      <p:sp>
-        <p:nvSpPr>
-          <p:cNvPr id="25" name="TextBox 24"/>
-          <p:cNvSpPr txBox="1"/>
-          <p:nvPr/>
-        </p:nvSpPr>
-        <p:spPr>
-          <a:xfrm>
-            <a:off x="594360" y="3131528"/>
-            <a:ext cx="2537460" cy="438912"/>
-          </a:xfrm>
-          <a:prstGeom prst="rect">
-            <a:avLst/>
-          </a:prstGeom>
-          <a:noFill/>
-        </p:spPr>
-        <p:txBody>
-          <a:bodyPr wrap="square">
-            <a:spAutoFit/>
-          </a:bodyPr>
-          <a:lstStyle/>
-          <a:p>
-            <a:pPr algn="l"/>
-            <a:r>
-              <a:rPr sz="1300" b="0">
-                <a:solidFill>
-                  <a:srgbClr val="B8C0CC"/>
-                </a:solidFill>
-                <a:latin typeface="Calibri"/>
-              </a:rPr>
-              <a:t>Topic modeling</a:t>
-            </a:r>
-          </a:p>
-        </p:txBody>
-      </p:sp>
-      <p:sp>
-        <p:nvSpPr>
-          <p:cNvPr id="26" name="TextBox 25"/>
-          <p:cNvSpPr txBox="1"/>
-          <p:nvPr/>
-        </p:nvSpPr>
-        <p:spPr>
-          <a:xfrm>
-            <a:off x="3223260" y="3131528"/>
-            <a:ext cx="2537460" cy="438912"/>
-          </a:xfrm>
-          <a:prstGeom prst="rect">
-            <a:avLst/>
-          </a:prstGeom>
-          <a:noFill/>
-        </p:spPr>
-        <p:txBody>
-          <a:bodyPr wrap="square">
-            <a:spAutoFit/>
-          </a:bodyPr>
-          <a:lstStyle/>
-          <a:p>
-            <a:pPr algn="l"/>
-            <a:r>
-              <a:rPr sz="1300" b="0">
-                <a:solidFill>
-                  <a:srgbClr val="B8C0CC"/>
-                </a:solidFill>
-                <a:latin typeface="Calibri"/>
-              </a:rPr>
-              <a:t>Con modelo multilingüe</a:t>
-            </a:r>
-          </a:p>
-        </p:txBody>
-      </p:sp>
-      <p:sp>
-        <p:nvSpPr>
-          <p:cNvPr id="27" name="TextBox 26"/>
-          <p:cNvSpPr txBox="1"/>
-          <p:nvPr/>
-        </p:nvSpPr>
-        <p:spPr>
-          <a:xfrm>
-            <a:off x="5852160" y="3131528"/>
-            <a:ext cx="2537460" cy="438912"/>
-          </a:xfrm>
-          <a:prstGeom prst="rect">
-            <a:avLst/>
-          </a:prstGeom>
-          <a:noFill/>
-        </p:spPr>
-        <p:txBody>
-          <a:bodyPr wrap="square">
-            <a:spAutoFit/>
-          </a:bodyPr>
-          <a:lstStyle/>
-          <a:p>
-            <a:pPr algn="l"/>
-            <a:r>
-              <a:rPr sz="1300" b="0">
-                <a:solidFill>
-                  <a:srgbClr val="B8C0CC"/>
-                </a:solidFill>
-                <a:latin typeface="Calibri"/>
-              </a:rPr>
-              <a:t>✓ si no hay modelo del idioma</a:t>
-            </a:r>
-          </a:p>
-        </p:txBody>
-      </p:sp>
-      <p:sp>
-        <p:nvSpPr>
-          <p:cNvPr id="28" name="TextBox 27"/>
-          <p:cNvSpPr txBox="1"/>
-          <p:nvPr/>
-        </p:nvSpPr>
-        <p:spPr>
-          <a:xfrm>
-            <a:off x="8481060" y="3131528"/>
-            <a:ext cx="2537460" cy="438912"/>
-          </a:xfrm>
-          <a:prstGeom prst="rect">
-            <a:avLst/>
-          </a:prstGeom>
-          <a:noFill/>
-        </p:spPr>
-        <p:txBody>
-          <a:bodyPr wrap="square">
-            <a:spAutoFit/>
-          </a:bodyPr>
-          <a:lstStyle/>
-          <a:p>
-            <a:pPr algn="l"/>
-            <a:r>
-              <a:rPr sz="1300" b="0">
-                <a:solidFill>
-                  <a:srgbClr val="B8C0CC"/>
-                </a:solidFill>
-                <a:latin typeface="Calibri"/>
-              </a:rPr>
-              <a:t>Los topics son semánticos, no estilísticos</a:t>
-            </a:r>
-          </a:p>
-        </p:txBody>
-      </p:sp>
-    </p:spTree>
-  </p:cSld>
-  <p:clrMapOvr>
-    <a:masterClrMapping/>
-  </p:clrMapOvr>
-</p:sld>
-</file>
-
-<file path=ppt/slides/slide12.xml><?xml version="1.0" encoding="utf-8"?>
-<p:sld xmlns:a="http://schemas.openxmlformats.org/drawingml/2006/main" xmlns:p="http://schemas.openxmlformats.org/presentationml/2006/main" xmlns:r="http://schemas.openxmlformats.org/officeDocument/2006/relationships">
-  <p:cSld>
-    <p:bg>
-      <p:bgPr>
-        <a:solidFill>
-          <a:srgbClr val="0F0F20"/>
-        </a:solidFill>
-        <a:effectLst/>
-      </p:bgPr>
-    </p:bg>
-    <p:spTree>
-      <p:nvGrpSpPr>
-        <p:cNvPr id="1" name=""/>
-        <p:cNvGrpSpPr/>
-        <p:nvPr/>
-      </p:nvGrpSpPr>
-      <p:grpSpPr/>
-      <p:sp>
-        <p:nvSpPr>
-          <p:cNvPr id="2" name="Rectangle 1"/>
-          <p:cNvSpPr/>
-          <p:nvPr/>
-        </p:nvSpPr>
-        <p:spPr>
-          <a:xfrm>
-            <a:off x="0" y="0"/>
-            <a:ext cx="12188952" cy="91440"/>
-          </a:xfrm>
-          <a:prstGeom prst="rect">
-            <a:avLst/>
-          </a:prstGeom>
-          <a:solidFill>
-            <a:srgbClr val="E94E4E"/>
-          </a:solidFill>
-          <a:ln>
-            <a:noFill/>
-          </a:ln>
-        </p:spPr>
-        <p:style>
-          <a:lnRef idx="1">
-            <a:schemeClr val="accent1"/>
-          </a:lnRef>
-          <a:fillRef idx="3">
-            <a:schemeClr val="accent1"/>
-          </a:fillRef>
-          <a:effectRef idx="2">
-            <a:schemeClr val="accent1"/>
-          </a:effectRef>
-          <a:fontRef idx="minor">
-            <a:schemeClr val="lt1"/>
-          </a:fontRef>
-        </p:style>
-        <p:txBody>
-          <a:bodyPr rtlCol="0" anchor="ctr"/>
-          <a:lstStyle/>
-          <a:p>
-            <a:pPr algn="ctr"/>
-          </a:p>
-        </p:txBody>
-      </p:sp>
-      <p:sp>
-        <p:nvSpPr>
-          <p:cNvPr id="3" name="TextBox 2"/>
-          <p:cNvSpPr txBox="1"/>
-          <p:nvPr/>
-        </p:nvSpPr>
-        <p:spPr>
-          <a:xfrm>
-            <a:off x="8686800" y="731520"/>
-            <a:ext cx="3200400" cy="4572000"/>
-          </a:xfrm>
-          <a:prstGeom prst="rect">
-            <a:avLst/>
-          </a:prstGeom>
-          <a:noFill/>
-        </p:spPr>
-        <p:txBody>
-          <a:bodyPr wrap="square">
-            <a:spAutoFit/>
-          </a:bodyPr>
-          <a:lstStyle/>
-          <a:p>
-            <a:pPr algn="r"/>
-            <a:r>
-              <a:rPr sz="20000" b="1">
-                <a:solidFill>
-                  <a:srgbClr val="252545"/>
-                </a:solidFill>
-                <a:latin typeface="Calibri"/>
-              </a:rPr>
-              <a:t>4</a:t>
+              <a:t>NER zero-shot en dominio underground</a:t>
             </a:r>
           </a:p>
         </p:txBody>
@@ -4674,91 +3854,21 @@
         </p:nvSpPr>
         <p:spPr>
           <a:xfrm>
-            <a:off x="548640" y="2011680"/>
-            <a:ext cx="5486400" cy="457200"/>
-          </a:xfrm>
-          <a:prstGeom prst="rect">
-            <a:avLst/>
-          </a:prstGeom>
-          <a:noFill/>
-        </p:spPr>
-        <p:txBody>
-          <a:bodyPr wrap="square">
-            <a:spAutoFit/>
-          </a:bodyPr>
-          <a:lstStyle/>
-          <a:p>
-            <a:pPr algn="l"/>
-            <a:r>
-              <a:rPr sz="1300" b="1">
-                <a:solidFill>
-                  <a:srgbClr val="E94E4E"/>
-                </a:solidFill>
-                <a:latin typeface="Calibri"/>
-              </a:rPr>
-              <a:t>SECCIÓN</a:t>
-            </a:r>
-          </a:p>
-        </p:txBody>
-      </p:sp>
-      <p:sp>
-        <p:nvSpPr>
-          <p:cNvPr id="5" name="TextBox 4"/>
-          <p:cNvSpPr txBox="1"/>
-          <p:nvPr/>
-        </p:nvSpPr>
-        <p:spPr>
-          <a:xfrm>
-            <a:off x="548640" y="2468880"/>
-            <a:ext cx="8229600" cy="1645920"/>
-          </a:xfrm>
-          <a:prstGeom prst="rect">
-            <a:avLst/>
-          </a:prstGeom>
-          <a:noFill/>
-        </p:spPr>
-        <p:txBody>
-          <a:bodyPr wrap="square">
-            <a:spAutoFit/>
-          </a:bodyPr>
-          <a:lstStyle/>
-          <a:p>
-            <a:pPr algn="l"/>
-            <a:r>
-              <a:rPr sz="4000" b="1">
-                <a:solidFill>
-                  <a:srgbClr val="FFFFFF"/>
-                </a:solidFill>
-                <a:latin typeface="Calibri"/>
-              </a:rPr>
-              <a:t>Estilometría computacional</a:t>
-            </a:r>
-          </a:p>
-        </p:txBody>
-      </p:sp>
-      <p:sp>
-        <p:nvSpPr>
-          <p:cNvPr id="6" name="TextBox 5"/>
-          <p:cNvSpPr txBox="1"/>
-          <p:nvPr/>
-        </p:nvSpPr>
-        <p:spPr>
-          <a:xfrm>
-            <a:off x="548640" y="4206240"/>
-            <a:ext cx="8229600" cy="731520"/>
-          </a:xfrm>
-          <a:prstGeom prst="rect">
-            <a:avLst/>
-          </a:prstGeom>
-          <a:noFill/>
-        </p:spPr>
-        <p:txBody>
-          <a:bodyPr wrap="square">
-            <a:spAutoFit/>
-          </a:bodyPr>
-          <a:lstStyle/>
-          <a:p>
-            <a:pPr algn="l"/>
+            <a:off x="548640" y="1371600"/>
+            <a:ext cx="11064240" cy="5029200"/>
+          </a:xfrm>
+          <a:prstGeom prst="rect">
+            <a:avLst/>
+          </a:prstGeom>
+          <a:noFill/>
+        </p:spPr>
+        <p:txBody>
+          <a:bodyPr wrap="square">
+            <a:spAutoFit/>
+          </a:bodyPr>
+          <a:lstStyle/>
+          <a:p>
+            <a:pPr algn="l" marL="0" indent="-228600"/>
             <a:r>
               <a:rPr sz="2000" b="0">
                 <a:solidFill>
@@ -4766,7 +3876,67 @@
                 </a:solidFill>
                 <a:latin typeface="Calibri"/>
               </a:rPr>
-              <a:t>La huella digital del escritor</a:t>
+              <a:t>▸  NER estándar (spaCy, BERT) falla: no fue entrenado con texto underground</a:t>
+            </a:r>
+          </a:p>
+          <a:p>
+            <a:pPr algn="l" marL="0" indent="-228600"/>
+            <a:r>
+              <a:rPr sz="2000" b="0">
+                <a:solidFill>
+                  <a:srgbClr val="B8C0CC"/>
+                </a:solidFill>
+                <a:latin typeface="Calibri"/>
+              </a:rPr>
+              <a:t>▸  Zero-shot con LLM local: describir el tipo de entidad en el prompt, extraer directamente</a:t>
+            </a:r>
+          </a:p>
+          <a:p>
+            <a:pPr algn="l" marL="0" indent="-228600"/>
+            <a:r>
+              <a:rPr sz="2000" b="0">
+                <a:solidFill>
+                  <a:srgbClr val="B8C0CC"/>
+                </a:solidFill>
+                <a:latin typeface="Calibri"/>
+              </a:rPr>
+              <a:t>▸  Tipos de entidad útiles en este dominio: ALIAS, TOOL, MALWARE, CVE, MARKETPLACE, WALLET</a:t>
+            </a:r>
+          </a:p>
+          <a:p>
+            <a:pPr algn="l" marL="0" indent="-228600"/>
+            <a:r>
+              <a:rPr sz="2000" b="0">
+                <a:solidFill>
+                  <a:srgbClr val="B8C0CC"/>
+                </a:solidFill>
+                <a:latin typeface="Calibri"/>
+              </a:rPr>
+              <a:t>▸  Estrategia: muestra de top-N usuarios × top-M posts más largos + checkpoint automático</a:t>
+            </a:r>
+          </a:p>
+          <a:p>
+            <a:pPr algn="l" marL="0" indent="-228600"/>
+            <a:r>
+              <a:rPr sz="2000" b="0">
+                <a:solidFill>
+                  <a:srgbClr val="B8C0CC"/>
+                </a:solidFill>
+                <a:latin typeface="Calibri"/>
+              </a:rPr>
+              <a:t>▸  Para texto no inglés: el LLM rinde mejor en inglés → traducir el texto primero es aceptable</a:t>
+            </a:r>
+          </a:p>
+          <a:p>
+            <a:pPr algn="l" marL="0" indent="-228600"/>
+            <a:r>
+              <a:rPr sz="2000" b="0">
+                <a:solidFill>
+                  <a:srgbClr val="B8C0CC"/>
+                </a:solidFill>
+                <a:latin typeface="Calibri"/>
+              </a:rPr>
+              <a:t>▸  ¿Por qué es aceptable aquí? Para NER no importa el estilo, solo las entidades</a:t>
             </a:r>
           </a:p>
         </p:txBody>
@@ -4870,102 +4040,922 @@
                 </a:solidFill>
                 <a:latin typeface="Calibri"/>
               </a:rPr>
-              <a:t>Burrows' Delta — el estándar de atribución de autoría</a:t>
-            </a:r>
-          </a:p>
-        </p:txBody>
-      </p:sp>
-      <p:sp>
-        <p:nvSpPr>
-          <p:cNvPr id="4" name="TextBox 3"/>
-          <p:cNvSpPr txBox="1"/>
-          <p:nvPr/>
-        </p:nvSpPr>
-        <p:spPr>
-          <a:xfrm>
-            <a:off x="548640" y="1371600"/>
-            <a:ext cx="11064240" cy="5029200"/>
-          </a:xfrm>
-          <a:prstGeom prst="rect">
-            <a:avLst/>
-          </a:prstGeom>
-          <a:noFill/>
-        </p:spPr>
-        <p:txBody>
-          <a:bodyPr wrap="square">
-            <a:spAutoFit/>
-          </a:bodyPr>
-          <a:lstStyle/>
-          <a:p>
-            <a:pPr algn="l" marL="0" indent="-228600"/>
-            <a:r>
-              <a:rPr sz="2000" b="0">
-                <a:solidFill>
-                  <a:srgbClr val="B8C0CC"/>
-                </a:solidFill>
-                <a:latin typeface="Calibri"/>
-              </a:rPr>
-              <a:t>▸  Mide la distribución de frecuencias de las N palabras más comunes, normalizada por z-score</a:t>
-            </a:r>
-          </a:p>
-          <a:p>
-            <a:pPr algn="l" marL="0" indent="-228600"/>
-            <a:r>
-              <a:rPr sz="2000" b="0">
-                <a:solidFill>
-                  <a:srgbClr val="B8C0CC"/>
-                </a:solidFill>
-                <a:latin typeface="Calibri"/>
-              </a:rPr>
-              <a:t>▸  Esas palabras son las 'funcionales': artículos, preposiciones, conjunciones — difíciles de suprimir</a:t>
-            </a:r>
-          </a:p>
-          <a:p>
-            <a:pPr algn="l" marL="0" indent="-228600"/>
-            <a:r>
-              <a:rPr sz="2000" b="0">
-                <a:solidFill>
-                  <a:srgbClr val="B8C0CC"/>
-                </a:solidFill>
-                <a:latin typeface="Calibri"/>
-              </a:rPr>
-              <a:t>▸  Delta bajo entre dos textos → mismo perfil de frecuencias → mismo autor probable</a:t>
-            </a:r>
-          </a:p>
-          <a:p>
-            <a:pPr algn="l" marL="0" indent="-228600"/>
-            <a:r>
-              <a:rPr sz="2000" b="0">
-                <a:solidFill>
-                  <a:srgbClr val="B8C0CC"/>
-                </a:solidFill>
-                <a:latin typeface="Calibri"/>
-              </a:rPr>
-              <a:t>▸  No depende del tema — solo del estilo de escritura</a:t>
-            </a:r>
-          </a:p>
-          <a:p>
-            <a:pPr algn="l" marL="0" indent="-228600"/>
-            <a:r>
-              <a:rPr sz="2000" b="0">
-                <a:solidFill>
-                  <a:srgbClr val="B8C0CC"/>
-                </a:solidFill>
-                <a:latin typeface="Calibri"/>
-              </a:rPr>
-              <a:t>▸  Limitación: en corpus ideológicamente homogéneo el poder discriminante baja (vocabulario compartido)</a:t>
-            </a:r>
-          </a:p>
-          <a:p>
-            <a:pPr algn="l" marL="0" indent="-228600"/>
-            <a:r>
-              <a:rPr sz="2000" b="0">
-                <a:solidFill>
-                  <a:srgbClr val="B8C0CC"/>
-                </a:solidFill>
-                <a:latin typeface="Calibri"/>
-              </a:rPr>
-              <a:t>▸  Complementar siempre con señales independientes: temporal, red, handle matching</a:t>
+              <a:t>Idioma original vs. traducción — regla según técnica</a:t>
+            </a:r>
+          </a:p>
+        </p:txBody>
+      </p:sp>
+      <p:sp>
+        <p:nvSpPr>
+          <p:cNvPr id="4" name="Rectangle 3"/>
+          <p:cNvSpPr/>
+          <p:nvPr/>
+        </p:nvSpPr>
+        <p:spPr>
+          <a:xfrm>
+            <a:off x="548640" y="1325880"/>
+            <a:ext cx="10515600" cy="438912"/>
+          </a:xfrm>
+          <a:prstGeom prst="rect">
+            <a:avLst/>
+          </a:prstGeom>
+          <a:solidFill>
+            <a:srgbClr val="E94E4E"/>
+          </a:solidFill>
+          <a:ln>
+            <a:noFill/>
+          </a:ln>
+        </p:spPr>
+        <p:style>
+          <a:lnRef idx="1">
+            <a:schemeClr val="accent1"/>
+          </a:lnRef>
+          <a:fillRef idx="3">
+            <a:schemeClr val="accent1"/>
+          </a:fillRef>
+          <a:effectRef idx="2">
+            <a:schemeClr val="accent1"/>
+          </a:effectRef>
+          <a:fontRef idx="minor">
+            <a:schemeClr val="lt1"/>
+          </a:fontRef>
+        </p:style>
+        <p:txBody>
+          <a:bodyPr rtlCol="0" anchor="ctr"/>
+          <a:lstStyle/>
+          <a:p>
+            <a:pPr algn="ctr"/>
+          </a:p>
+        </p:txBody>
+      </p:sp>
+      <p:sp>
+        <p:nvSpPr>
+          <p:cNvPr id="5" name="TextBox 4"/>
+          <p:cNvSpPr txBox="1"/>
+          <p:nvPr/>
+        </p:nvSpPr>
+        <p:spPr>
+          <a:xfrm>
+            <a:off x="594360" y="1385880"/>
+            <a:ext cx="2537460" cy="438912"/>
+          </a:xfrm>
+          <a:prstGeom prst="rect">
+            <a:avLst/>
+          </a:prstGeom>
+          <a:noFill/>
+        </p:spPr>
+        <p:txBody>
+          <a:bodyPr wrap="square">
+            <a:spAutoFit/>
+          </a:bodyPr>
+          <a:lstStyle/>
+          <a:p>
+            <a:pPr algn="l"/>
+            <a:r>
+              <a:rPr sz="1400" b="1">
+                <a:solidFill>
+                  <a:srgbClr val="FFFFFF"/>
+                </a:solidFill>
+                <a:latin typeface="Calibri"/>
+              </a:rPr>
+              <a:t>Técnica</a:t>
+            </a:r>
+          </a:p>
+        </p:txBody>
+      </p:sp>
+      <p:sp>
+        <p:nvSpPr>
+          <p:cNvPr id="6" name="TextBox 5"/>
+          <p:cNvSpPr txBox="1"/>
+          <p:nvPr/>
+        </p:nvSpPr>
+        <p:spPr>
+          <a:xfrm>
+            <a:off x="3223260" y="1385880"/>
+            <a:ext cx="2537460" cy="438912"/>
+          </a:xfrm>
+          <a:prstGeom prst="rect">
+            <a:avLst/>
+          </a:prstGeom>
+          <a:noFill/>
+        </p:spPr>
+        <p:txBody>
+          <a:bodyPr wrap="square">
+            <a:spAutoFit/>
+          </a:bodyPr>
+          <a:lstStyle/>
+          <a:p>
+            <a:pPr algn="l"/>
+            <a:r>
+              <a:rPr sz="1400" b="1">
+                <a:solidFill>
+                  <a:srgbClr val="FFFFFF"/>
+                </a:solidFill>
+                <a:latin typeface="Calibri"/>
+              </a:rPr>
+              <a:t>Original</a:t>
+            </a:r>
+          </a:p>
+        </p:txBody>
+      </p:sp>
+      <p:sp>
+        <p:nvSpPr>
+          <p:cNvPr id="7" name="TextBox 6"/>
+          <p:cNvSpPr txBox="1"/>
+          <p:nvPr/>
+        </p:nvSpPr>
+        <p:spPr>
+          <a:xfrm>
+            <a:off x="5852160" y="1385880"/>
+            <a:ext cx="2537460" cy="438912"/>
+          </a:xfrm>
+          <a:prstGeom prst="rect">
+            <a:avLst/>
+          </a:prstGeom>
+          <a:noFill/>
+        </p:spPr>
+        <p:txBody>
+          <a:bodyPr wrap="square">
+            <a:spAutoFit/>
+          </a:bodyPr>
+          <a:lstStyle/>
+          <a:p>
+            <a:pPr algn="l"/>
+            <a:r>
+              <a:rPr sz="1400" b="1">
+                <a:solidFill>
+                  <a:srgbClr val="FFFFFF"/>
+                </a:solidFill>
+                <a:latin typeface="Calibri"/>
+              </a:rPr>
+              <a:t>Traducción</a:t>
+            </a:r>
+          </a:p>
+        </p:txBody>
+      </p:sp>
+      <p:sp>
+        <p:nvSpPr>
+          <p:cNvPr id="8" name="TextBox 7"/>
+          <p:cNvSpPr txBox="1"/>
+          <p:nvPr/>
+        </p:nvSpPr>
+        <p:spPr>
+          <a:xfrm>
+            <a:off x="8481060" y="1385880"/>
+            <a:ext cx="2537460" cy="438912"/>
+          </a:xfrm>
+          <a:prstGeom prst="rect">
+            <a:avLst/>
+          </a:prstGeom>
+          <a:noFill/>
+        </p:spPr>
+        <p:txBody>
+          <a:bodyPr wrap="square">
+            <a:spAutoFit/>
+          </a:bodyPr>
+          <a:lstStyle/>
+          <a:p>
+            <a:pPr algn="l"/>
+            <a:r>
+              <a:rPr sz="1400" b="1">
+                <a:solidFill>
+                  <a:srgbClr val="FFFFFF"/>
+                </a:solidFill>
+                <a:latin typeface="Calibri"/>
+              </a:rPr>
+              <a:t>Por qué</a:t>
+            </a:r>
+          </a:p>
+        </p:txBody>
+      </p:sp>
+      <p:sp>
+        <p:nvSpPr>
+          <p:cNvPr id="9" name="Rectangle 8"/>
+          <p:cNvSpPr/>
+          <p:nvPr/>
+        </p:nvSpPr>
+        <p:spPr>
+          <a:xfrm>
+            <a:off x="548640" y="1764792"/>
+            <a:ext cx="10515600" cy="438912"/>
+          </a:xfrm>
+          <a:prstGeom prst="rect">
+            <a:avLst/>
+          </a:prstGeom>
+          <a:solidFill>
+            <a:srgbClr val="222240"/>
+          </a:solidFill>
+          <a:ln>
+            <a:noFill/>
+          </a:ln>
+        </p:spPr>
+        <p:style>
+          <a:lnRef idx="1">
+            <a:schemeClr val="accent1"/>
+          </a:lnRef>
+          <a:fillRef idx="3">
+            <a:schemeClr val="accent1"/>
+          </a:fillRef>
+          <a:effectRef idx="2">
+            <a:schemeClr val="accent1"/>
+          </a:effectRef>
+          <a:fontRef idx="minor">
+            <a:schemeClr val="lt1"/>
+          </a:fontRef>
+        </p:style>
+        <p:txBody>
+          <a:bodyPr rtlCol="0" anchor="ctr"/>
+          <a:lstStyle/>
+          <a:p>
+            <a:pPr algn="ctr"/>
+          </a:p>
+        </p:txBody>
+      </p:sp>
+      <p:sp>
+        <p:nvSpPr>
+          <p:cNvPr id="10" name="TextBox 9"/>
+          <p:cNvSpPr txBox="1"/>
+          <p:nvPr/>
+        </p:nvSpPr>
+        <p:spPr>
+          <a:xfrm>
+            <a:off x="594360" y="1814792"/>
+            <a:ext cx="2537460" cy="438912"/>
+          </a:xfrm>
+          <a:prstGeom prst="rect">
+            <a:avLst/>
+          </a:prstGeom>
+          <a:noFill/>
+        </p:spPr>
+        <p:txBody>
+          <a:bodyPr wrap="square">
+            <a:spAutoFit/>
+          </a:bodyPr>
+          <a:lstStyle/>
+          <a:p>
+            <a:pPr algn="l"/>
+            <a:r>
+              <a:rPr sz="1300" b="0">
+                <a:solidFill>
+                  <a:srgbClr val="B8C0CC"/>
+                </a:solidFill>
+                <a:latin typeface="Calibri"/>
+              </a:rPr>
+              <a:t>Embeddings</a:t>
+            </a:r>
+          </a:p>
+        </p:txBody>
+      </p:sp>
+      <p:sp>
+        <p:nvSpPr>
+          <p:cNvPr id="11" name="TextBox 10"/>
+          <p:cNvSpPr txBox="1"/>
+          <p:nvPr/>
+        </p:nvSpPr>
+        <p:spPr>
+          <a:xfrm>
+            <a:off x="3223260" y="1814792"/>
+            <a:ext cx="2537460" cy="438912"/>
+          </a:xfrm>
+          <a:prstGeom prst="rect">
+            <a:avLst/>
+          </a:prstGeom>
+          <a:noFill/>
+        </p:spPr>
+        <p:txBody>
+          <a:bodyPr wrap="square">
+            <a:spAutoFit/>
+          </a:bodyPr>
+          <a:lstStyle/>
+          <a:p>
+            <a:pPr algn="l"/>
+            <a:r>
+              <a:rPr sz="1300" b="0">
+                <a:solidFill>
+                  <a:srgbClr val="B8C0CC"/>
+                </a:solidFill>
+                <a:latin typeface="Calibri"/>
+              </a:rPr>
+              <a:t>✓ SIEMPRE</a:t>
+            </a:r>
+          </a:p>
+        </p:txBody>
+      </p:sp>
+      <p:sp>
+        <p:nvSpPr>
+          <p:cNvPr id="12" name="TextBox 11"/>
+          <p:cNvSpPr txBox="1"/>
+          <p:nvPr/>
+        </p:nvSpPr>
+        <p:spPr>
+          <a:xfrm>
+            <a:off x="5852160" y="1814792"/>
+            <a:ext cx="2537460" cy="438912"/>
+          </a:xfrm>
+          <a:prstGeom prst="rect">
+            <a:avLst/>
+          </a:prstGeom>
+          <a:noFill/>
+        </p:spPr>
+        <p:txBody>
+          <a:bodyPr wrap="square">
+            <a:spAutoFit/>
+          </a:bodyPr>
+          <a:lstStyle/>
+          <a:p>
+            <a:pPr algn="l"/>
+            <a:r>
+              <a:rPr sz="1300" b="0">
+                <a:solidFill>
+                  <a:srgbClr val="B8C0CC"/>
+                </a:solidFill>
+                <a:latin typeface="Calibri"/>
+              </a:rPr>
+              <a:t>✗ nunca</a:t>
+            </a:r>
+          </a:p>
+        </p:txBody>
+      </p:sp>
+      <p:sp>
+        <p:nvSpPr>
+          <p:cNvPr id="13" name="TextBox 12"/>
+          <p:cNvSpPr txBox="1"/>
+          <p:nvPr/>
+        </p:nvSpPr>
+        <p:spPr>
+          <a:xfrm>
+            <a:off x="8481060" y="1814792"/>
+            <a:ext cx="2537460" cy="438912"/>
+          </a:xfrm>
+          <a:prstGeom prst="rect">
+            <a:avLst/>
+          </a:prstGeom>
+          <a:noFill/>
+        </p:spPr>
+        <p:txBody>
+          <a:bodyPr wrap="square">
+            <a:spAutoFit/>
+          </a:bodyPr>
+          <a:lstStyle/>
+          <a:p>
+            <a:pPr algn="l"/>
+            <a:r>
+              <a:rPr sz="1300" b="0">
+                <a:solidFill>
+                  <a:srgbClr val="B8C0CC"/>
+                </a:solidFill>
+                <a:latin typeface="Calibri"/>
+              </a:rPr>
+              <a:t>Traducir destruye la huella estilométrica del autor</a:t>
+            </a:r>
+          </a:p>
+        </p:txBody>
+      </p:sp>
+      <p:sp>
+        <p:nvSpPr>
+          <p:cNvPr id="14" name="Rectangle 13"/>
+          <p:cNvSpPr/>
+          <p:nvPr/>
+        </p:nvSpPr>
+        <p:spPr>
+          <a:xfrm>
+            <a:off x="548640" y="2203704"/>
+            <a:ext cx="10515600" cy="438912"/>
+          </a:xfrm>
+          <a:prstGeom prst="rect">
+            <a:avLst/>
+          </a:prstGeom>
+          <a:solidFill>
+            <a:srgbClr val="1E1E38"/>
+          </a:solidFill>
+          <a:ln>
+            <a:noFill/>
+          </a:ln>
+        </p:spPr>
+        <p:style>
+          <a:lnRef idx="1">
+            <a:schemeClr val="accent1"/>
+          </a:lnRef>
+          <a:fillRef idx="3">
+            <a:schemeClr val="accent1"/>
+          </a:fillRef>
+          <a:effectRef idx="2">
+            <a:schemeClr val="accent1"/>
+          </a:effectRef>
+          <a:fontRef idx="minor">
+            <a:schemeClr val="lt1"/>
+          </a:fontRef>
+        </p:style>
+        <p:txBody>
+          <a:bodyPr rtlCol="0" anchor="ctr"/>
+          <a:lstStyle/>
+          <a:p>
+            <a:pPr algn="ctr"/>
+          </a:p>
+        </p:txBody>
+      </p:sp>
+      <p:sp>
+        <p:nvSpPr>
+          <p:cNvPr id="15" name="TextBox 14"/>
+          <p:cNvSpPr txBox="1"/>
+          <p:nvPr/>
+        </p:nvSpPr>
+        <p:spPr>
+          <a:xfrm>
+            <a:off x="594360" y="2253704"/>
+            <a:ext cx="2537460" cy="438912"/>
+          </a:xfrm>
+          <a:prstGeom prst="rect">
+            <a:avLst/>
+          </a:prstGeom>
+          <a:noFill/>
+        </p:spPr>
+        <p:txBody>
+          <a:bodyPr wrap="square">
+            <a:spAutoFit/>
+          </a:bodyPr>
+          <a:lstStyle/>
+          <a:p>
+            <a:pPr algn="l"/>
+            <a:r>
+              <a:rPr sz="1300" b="0">
+                <a:solidFill>
+                  <a:srgbClr val="B8C0CC"/>
+                </a:solidFill>
+                <a:latin typeface="Calibri"/>
+              </a:rPr>
+              <a:t>Estilometría</a:t>
+            </a:r>
+          </a:p>
+        </p:txBody>
+      </p:sp>
+      <p:sp>
+        <p:nvSpPr>
+          <p:cNvPr id="16" name="TextBox 15"/>
+          <p:cNvSpPr txBox="1"/>
+          <p:nvPr/>
+        </p:nvSpPr>
+        <p:spPr>
+          <a:xfrm>
+            <a:off x="3223260" y="2253704"/>
+            <a:ext cx="2537460" cy="438912"/>
+          </a:xfrm>
+          <a:prstGeom prst="rect">
+            <a:avLst/>
+          </a:prstGeom>
+          <a:noFill/>
+        </p:spPr>
+        <p:txBody>
+          <a:bodyPr wrap="square">
+            <a:spAutoFit/>
+          </a:bodyPr>
+          <a:lstStyle/>
+          <a:p>
+            <a:pPr algn="l"/>
+            <a:r>
+              <a:rPr sz="1300" b="0">
+                <a:solidFill>
+                  <a:srgbClr val="B8C0CC"/>
+                </a:solidFill>
+                <a:latin typeface="Calibri"/>
+              </a:rPr>
+              <a:t>✓ SIEMPRE</a:t>
+            </a:r>
+          </a:p>
+        </p:txBody>
+      </p:sp>
+      <p:sp>
+        <p:nvSpPr>
+          <p:cNvPr id="17" name="TextBox 16"/>
+          <p:cNvSpPr txBox="1"/>
+          <p:nvPr/>
+        </p:nvSpPr>
+        <p:spPr>
+          <a:xfrm>
+            <a:off x="5852160" y="2253704"/>
+            <a:ext cx="2537460" cy="438912"/>
+          </a:xfrm>
+          <a:prstGeom prst="rect">
+            <a:avLst/>
+          </a:prstGeom>
+          <a:noFill/>
+        </p:spPr>
+        <p:txBody>
+          <a:bodyPr wrap="square">
+            <a:spAutoFit/>
+          </a:bodyPr>
+          <a:lstStyle/>
+          <a:p>
+            <a:pPr algn="l"/>
+            <a:r>
+              <a:rPr sz="1300" b="0">
+                <a:solidFill>
+                  <a:srgbClr val="B8C0CC"/>
+                </a:solidFill>
+                <a:latin typeface="Calibri"/>
+              </a:rPr>
+              <a:t>✗ nunca</a:t>
+            </a:r>
+          </a:p>
+        </p:txBody>
+      </p:sp>
+      <p:sp>
+        <p:nvSpPr>
+          <p:cNvPr id="18" name="TextBox 17"/>
+          <p:cNvSpPr txBox="1"/>
+          <p:nvPr/>
+        </p:nvSpPr>
+        <p:spPr>
+          <a:xfrm>
+            <a:off x="8481060" y="2253704"/>
+            <a:ext cx="2537460" cy="438912"/>
+          </a:xfrm>
+          <a:prstGeom prst="rect">
+            <a:avLst/>
+          </a:prstGeom>
+          <a:noFill/>
+        </p:spPr>
+        <p:txBody>
+          <a:bodyPr wrap="square">
+            <a:spAutoFit/>
+          </a:bodyPr>
+          <a:lstStyle/>
+          <a:p>
+            <a:pPr algn="l"/>
+            <a:r>
+              <a:rPr sz="1300" b="0">
+                <a:solidFill>
+                  <a:srgbClr val="B8C0CC"/>
+                </a:solidFill>
+                <a:latin typeface="Calibri"/>
+              </a:rPr>
+              <a:t>La señal ES el estilo — no sobrevive la traducción</a:t>
+            </a:r>
+          </a:p>
+        </p:txBody>
+      </p:sp>
+      <p:sp>
+        <p:nvSpPr>
+          <p:cNvPr id="19" name="Rectangle 18"/>
+          <p:cNvSpPr/>
+          <p:nvPr/>
+        </p:nvSpPr>
+        <p:spPr>
+          <a:xfrm>
+            <a:off x="548640" y="2642616"/>
+            <a:ext cx="10515600" cy="438912"/>
+          </a:xfrm>
+          <a:prstGeom prst="rect">
+            <a:avLst/>
+          </a:prstGeom>
+          <a:solidFill>
+            <a:srgbClr val="222240"/>
+          </a:solidFill>
+          <a:ln>
+            <a:noFill/>
+          </a:ln>
+        </p:spPr>
+        <p:style>
+          <a:lnRef idx="1">
+            <a:schemeClr val="accent1"/>
+          </a:lnRef>
+          <a:fillRef idx="3">
+            <a:schemeClr val="accent1"/>
+          </a:fillRef>
+          <a:effectRef idx="2">
+            <a:schemeClr val="accent1"/>
+          </a:effectRef>
+          <a:fontRef idx="minor">
+            <a:schemeClr val="lt1"/>
+          </a:fontRef>
+        </p:style>
+        <p:txBody>
+          <a:bodyPr rtlCol="0" anchor="ctr"/>
+          <a:lstStyle/>
+          <a:p>
+            <a:pPr algn="ctr"/>
+          </a:p>
+        </p:txBody>
+      </p:sp>
+      <p:sp>
+        <p:nvSpPr>
+          <p:cNvPr id="20" name="TextBox 19"/>
+          <p:cNvSpPr txBox="1"/>
+          <p:nvPr/>
+        </p:nvSpPr>
+        <p:spPr>
+          <a:xfrm>
+            <a:off x="594360" y="2692616"/>
+            <a:ext cx="2537460" cy="438912"/>
+          </a:xfrm>
+          <a:prstGeom prst="rect">
+            <a:avLst/>
+          </a:prstGeom>
+          <a:noFill/>
+        </p:spPr>
+        <p:txBody>
+          <a:bodyPr wrap="square">
+            <a:spAutoFit/>
+          </a:bodyPr>
+          <a:lstStyle/>
+          <a:p>
+            <a:pPr algn="l"/>
+            <a:r>
+              <a:rPr sz="1300" b="0">
+                <a:solidFill>
+                  <a:srgbClr val="B8C0CC"/>
+                </a:solidFill>
+                <a:latin typeface="Calibri"/>
+              </a:rPr>
+              <a:t>NER con LLM</a:t>
+            </a:r>
+          </a:p>
+        </p:txBody>
+      </p:sp>
+      <p:sp>
+        <p:nvSpPr>
+          <p:cNvPr id="21" name="TextBox 20"/>
+          <p:cNvSpPr txBox="1"/>
+          <p:nvPr/>
+        </p:nvSpPr>
+        <p:spPr>
+          <a:xfrm>
+            <a:off x="3223260" y="2692616"/>
+            <a:ext cx="2537460" cy="438912"/>
+          </a:xfrm>
+          <a:prstGeom prst="rect">
+            <a:avLst/>
+          </a:prstGeom>
+          <a:noFill/>
+        </p:spPr>
+        <p:txBody>
+          <a:bodyPr wrap="square">
+            <a:spAutoFit/>
+          </a:bodyPr>
+          <a:lstStyle/>
+          <a:p>
+            <a:pPr algn="l"/>
+            <a:r>
+              <a:rPr sz="1300" b="0">
+                <a:solidFill>
+                  <a:srgbClr val="B8C0CC"/>
+                </a:solidFill>
+                <a:latin typeface="Calibri"/>
+              </a:rPr>
+              <a:t>Si el modelo lo soporta bien</a:t>
+            </a:r>
+          </a:p>
+        </p:txBody>
+      </p:sp>
+      <p:sp>
+        <p:nvSpPr>
+          <p:cNvPr id="22" name="TextBox 21"/>
+          <p:cNvSpPr txBox="1"/>
+          <p:nvPr/>
+        </p:nvSpPr>
+        <p:spPr>
+          <a:xfrm>
+            <a:off x="5852160" y="2692616"/>
+            <a:ext cx="2537460" cy="438912"/>
+          </a:xfrm>
+          <a:prstGeom prst="rect">
+            <a:avLst/>
+          </a:prstGeom>
+          <a:noFill/>
+        </p:spPr>
+        <p:txBody>
+          <a:bodyPr wrap="square">
+            <a:spAutoFit/>
+          </a:bodyPr>
+          <a:lstStyle/>
+          <a:p>
+            <a:pPr algn="l"/>
+            <a:r>
+              <a:rPr sz="1300" b="0">
+                <a:solidFill>
+                  <a:srgbClr val="B8C0CC"/>
+                </a:solidFill>
+                <a:latin typeface="Calibri"/>
+              </a:rPr>
+              <a:t>✓ si el modelo base es inglés</a:t>
+            </a:r>
+          </a:p>
+        </p:txBody>
+      </p:sp>
+      <p:sp>
+        <p:nvSpPr>
+          <p:cNvPr id="23" name="TextBox 22"/>
+          <p:cNvSpPr txBox="1"/>
+          <p:nvPr/>
+        </p:nvSpPr>
+        <p:spPr>
+          <a:xfrm>
+            <a:off x="8481060" y="2692616"/>
+            <a:ext cx="2537460" cy="438912"/>
+          </a:xfrm>
+          <a:prstGeom prst="rect">
+            <a:avLst/>
+          </a:prstGeom>
+          <a:noFill/>
+        </p:spPr>
+        <p:txBody>
+          <a:bodyPr wrap="square">
+            <a:spAutoFit/>
+          </a:bodyPr>
+          <a:lstStyle/>
+          <a:p>
+            <a:pPr algn="l"/>
+            <a:r>
+              <a:rPr sz="1300" b="0">
+                <a:solidFill>
+                  <a:srgbClr val="B8C0CC"/>
+                </a:solidFill>
+                <a:latin typeface="Calibri"/>
+              </a:rPr>
+              <a:t>Para NER importa la entidad, no el estilo</a:t>
+            </a:r>
+          </a:p>
+        </p:txBody>
+      </p:sp>
+      <p:sp>
+        <p:nvSpPr>
+          <p:cNvPr id="24" name="Rectangle 23"/>
+          <p:cNvSpPr/>
+          <p:nvPr/>
+        </p:nvSpPr>
+        <p:spPr>
+          <a:xfrm>
+            <a:off x="548640" y="3081528"/>
+            <a:ext cx="10515600" cy="438912"/>
+          </a:xfrm>
+          <a:prstGeom prst="rect">
+            <a:avLst/>
+          </a:prstGeom>
+          <a:solidFill>
+            <a:srgbClr val="1E1E38"/>
+          </a:solidFill>
+          <a:ln>
+            <a:noFill/>
+          </a:ln>
+        </p:spPr>
+        <p:style>
+          <a:lnRef idx="1">
+            <a:schemeClr val="accent1"/>
+          </a:lnRef>
+          <a:fillRef idx="3">
+            <a:schemeClr val="accent1"/>
+          </a:fillRef>
+          <a:effectRef idx="2">
+            <a:schemeClr val="accent1"/>
+          </a:effectRef>
+          <a:fontRef idx="minor">
+            <a:schemeClr val="lt1"/>
+          </a:fontRef>
+        </p:style>
+        <p:txBody>
+          <a:bodyPr rtlCol="0" anchor="ctr"/>
+          <a:lstStyle/>
+          <a:p>
+            <a:pPr algn="ctr"/>
+          </a:p>
+        </p:txBody>
+      </p:sp>
+      <p:sp>
+        <p:nvSpPr>
+          <p:cNvPr id="25" name="TextBox 24"/>
+          <p:cNvSpPr txBox="1"/>
+          <p:nvPr/>
+        </p:nvSpPr>
+        <p:spPr>
+          <a:xfrm>
+            <a:off x="594360" y="3131528"/>
+            <a:ext cx="2537460" cy="438912"/>
+          </a:xfrm>
+          <a:prstGeom prst="rect">
+            <a:avLst/>
+          </a:prstGeom>
+          <a:noFill/>
+        </p:spPr>
+        <p:txBody>
+          <a:bodyPr wrap="square">
+            <a:spAutoFit/>
+          </a:bodyPr>
+          <a:lstStyle/>
+          <a:p>
+            <a:pPr algn="l"/>
+            <a:r>
+              <a:rPr sz="1300" b="0">
+                <a:solidFill>
+                  <a:srgbClr val="B8C0CC"/>
+                </a:solidFill>
+                <a:latin typeface="Calibri"/>
+              </a:rPr>
+              <a:t>Topic modeling</a:t>
+            </a:r>
+          </a:p>
+        </p:txBody>
+      </p:sp>
+      <p:sp>
+        <p:nvSpPr>
+          <p:cNvPr id="26" name="TextBox 25"/>
+          <p:cNvSpPr txBox="1"/>
+          <p:nvPr/>
+        </p:nvSpPr>
+        <p:spPr>
+          <a:xfrm>
+            <a:off x="3223260" y="3131528"/>
+            <a:ext cx="2537460" cy="438912"/>
+          </a:xfrm>
+          <a:prstGeom prst="rect">
+            <a:avLst/>
+          </a:prstGeom>
+          <a:noFill/>
+        </p:spPr>
+        <p:txBody>
+          <a:bodyPr wrap="square">
+            <a:spAutoFit/>
+          </a:bodyPr>
+          <a:lstStyle/>
+          <a:p>
+            <a:pPr algn="l"/>
+            <a:r>
+              <a:rPr sz="1300" b="0">
+                <a:solidFill>
+                  <a:srgbClr val="B8C0CC"/>
+                </a:solidFill>
+                <a:latin typeface="Calibri"/>
+              </a:rPr>
+              <a:t>Con modelo multilingüe</a:t>
+            </a:r>
+          </a:p>
+        </p:txBody>
+      </p:sp>
+      <p:sp>
+        <p:nvSpPr>
+          <p:cNvPr id="27" name="TextBox 26"/>
+          <p:cNvSpPr txBox="1"/>
+          <p:nvPr/>
+        </p:nvSpPr>
+        <p:spPr>
+          <a:xfrm>
+            <a:off x="5852160" y="3131528"/>
+            <a:ext cx="2537460" cy="438912"/>
+          </a:xfrm>
+          <a:prstGeom prst="rect">
+            <a:avLst/>
+          </a:prstGeom>
+          <a:noFill/>
+        </p:spPr>
+        <p:txBody>
+          <a:bodyPr wrap="square">
+            <a:spAutoFit/>
+          </a:bodyPr>
+          <a:lstStyle/>
+          <a:p>
+            <a:pPr algn="l"/>
+            <a:r>
+              <a:rPr sz="1300" b="0">
+                <a:solidFill>
+                  <a:srgbClr val="B8C0CC"/>
+                </a:solidFill>
+                <a:latin typeface="Calibri"/>
+              </a:rPr>
+              <a:t>✓ si no hay modelo del idioma</a:t>
+            </a:r>
+          </a:p>
+        </p:txBody>
+      </p:sp>
+      <p:sp>
+        <p:nvSpPr>
+          <p:cNvPr id="28" name="TextBox 27"/>
+          <p:cNvSpPr txBox="1"/>
+          <p:nvPr/>
+        </p:nvSpPr>
+        <p:spPr>
+          <a:xfrm>
+            <a:off x="8481060" y="3131528"/>
+            <a:ext cx="2537460" cy="438912"/>
+          </a:xfrm>
+          <a:prstGeom prst="rect">
+            <a:avLst/>
+          </a:prstGeom>
+          <a:noFill/>
+        </p:spPr>
+        <p:txBody>
+          <a:bodyPr wrap="square">
+            <a:spAutoFit/>
+          </a:bodyPr>
+          <a:lstStyle/>
+          <a:p>
+            <a:pPr algn="l"/>
+            <a:r>
+              <a:rPr sz="1300" b="0">
+                <a:solidFill>
+                  <a:srgbClr val="B8C0CC"/>
+                </a:solidFill>
+                <a:latin typeface="Calibri"/>
+              </a:rPr>
+              <a:t>Los topics son semánticos, no estilísticos</a:t>
             </a:r>
           </a:p>
         </p:txBody>
@@ -4979,6 +4969,215 @@
 </file>
 
 <file path=ppt/slides/slide14.xml><?xml version="1.0" encoding="utf-8"?>
+<p:sld xmlns:a="http://schemas.openxmlformats.org/drawingml/2006/main" xmlns:p="http://schemas.openxmlformats.org/presentationml/2006/main" xmlns:r="http://schemas.openxmlformats.org/officeDocument/2006/relationships">
+  <p:cSld>
+    <p:bg>
+      <p:bgPr>
+        <a:solidFill>
+          <a:srgbClr val="0F0F20"/>
+        </a:solidFill>
+        <a:effectLst/>
+      </p:bgPr>
+    </p:bg>
+    <p:spTree>
+      <p:nvGrpSpPr>
+        <p:cNvPr id="1" name=""/>
+        <p:cNvGrpSpPr/>
+        <p:nvPr/>
+      </p:nvGrpSpPr>
+      <p:grpSpPr/>
+      <p:sp>
+        <p:nvSpPr>
+          <p:cNvPr id="2" name="Rectangle 1"/>
+          <p:cNvSpPr/>
+          <p:nvPr/>
+        </p:nvSpPr>
+        <p:spPr>
+          <a:xfrm>
+            <a:off x="0" y="0"/>
+            <a:ext cx="12188952" cy="91440"/>
+          </a:xfrm>
+          <a:prstGeom prst="rect">
+            <a:avLst/>
+          </a:prstGeom>
+          <a:solidFill>
+            <a:srgbClr val="E94E4E"/>
+          </a:solidFill>
+          <a:ln>
+            <a:noFill/>
+          </a:ln>
+        </p:spPr>
+        <p:style>
+          <a:lnRef idx="1">
+            <a:schemeClr val="accent1"/>
+          </a:lnRef>
+          <a:fillRef idx="3">
+            <a:schemeClr val="accent1"/>
+          </a:fillRef>
+          <a:effectRef idx="2">
+            <a:schemeClr val="accent1"/>
+          </a:effectRef>
+          <a:fontRef idx="minor">
+            <a:schemeClr val="lt1"/>
+          </a:fontRef>
+        </p:style>
+        <p:txBody>
+          <a:bodyPr rtlCol="0" anchor="ctr"/>
+          <a:lstStyle/>
+          <a:p>
+            <a:pPr algn="ctr"/>
+          </a:p>
+        </p:txBody>
+      </p:sp>
+      <p:sp>
+        <p:nvSpPr>
+          <p:cNvPr id="3" name="TextBox 2"/>
+          <p:cNvSpPr txBox="1"/>
+          <p:nvPr/>
+        </p:nvSpPr>
+        <p:spPr>
+          <a:xfrm>
+            <a:off x="8686800" y="731520"/>
+            <a:ext cx="3200400" cy="4572000"/>
+          </a:xfrm>
+          <a:prstGeom prst="rect">
+            <a:avLst/>
+          </a:prstGeom>
+          <a:noFill/>
+        </p:spPr>
+        <p:txBody>
+          <a:bodyPr wrap="square">
+            <a:spAutoFit/>
+          </a:bodyPr>
+          <a:lstStyle/>
+          <a:p>
+            <a:pPr algn="r"/>
+            <a:r>
+              <a:rPr sz="20000" b="1">
+                <a:solidFill>
+                  <a:srgbClr val="252545"/>
+                </a:solidFill>
+                <a:latin typeface="Calibri"/>
+              </a:rPr>
+              <a:t>4</a:t>
+            </a:r>
+          </a:p>
+        </p:txBody>
+      </p:sp>
+      <p:sp>
+        <p:nvSpPr>
+          <p:cNvPr id="4" name="TextBox 3"/>
+          <p:cNvSpPr txBox="1"/>
+          <p:nvPr/>
+        </p:nvSpPr>
+        <p:spPr>
+          <a:xfrm>
+            <a:off x="548640" y="2011680"/>
+            <a:ext cx="5486400" cy="457200"/>
+          </a:xfrm>
+          <a:prstGeom prst="rect">
+            <a:avLst/>
+          </a:prstGeom>
+          <a:noFill/>
+        </p:spPr>
+        <p:txBody>
+          <a:bodyPr wrap="square">
+            <a:spAutoFit/>
+          </a:bodyPr>
+          <a:lstStyle/>
+          <a:p>
+            <a:pPr algn="l"/>
+            <a:r>
+              <a:rPr sz="1300" b="1">
+                <a:solidFill>
+                  <a:srgbClr val="E94E4E"/>
+                </a:solidFill>
+                <a:latin typeface="Calibri"/>
+              </a:rPr>
+              <a:t>SECCIÓN</a:t>
+            </a:r>
+          </a:p>
+        </p:txBody>
+      </p:sp>
+      <p:sp>
+        <p:nvSpPr>
+          <p:cNvPr id="5" name="TextBox 4"/>
+          <p:cNvSpPr txBox="1"/>
+          <p:nvPr/>
+        </p:nvSpPr>
+        <p:spPr>
+          <a:xfrm>
+            <a:off x="548640" y="2468880"/>
+            <a:ext cx="8229600" cy="1645920"/>
+          </a:xfrm>
+          <a:prstGeom prst="rect">
+            <a:avLst/>
+          </a:prstGeom>
+          <a:noFill/>
+        </p:spPr>
+        <p:txBody>
+          <a:bodyPr wrap="square">
+            <a:spAutoFit/>
+          </a:bodyPr>
+          <a:lstStyle/>
+          <a:p>
+            <a:pPr algn="l"/>
+            <a:r>
+              <a:rPr sz="4000" b="1">
+                <a:solidFill>
+                  <a:srgbClr val="FFFFFF"/>
+                </a:solidFill>
+                <a:latin typeface="Calibri"/>
+              </a:rPr>
+              <a:t>Estilometría computacional</a:t>
+            </a:r>
+          </a:p>
+        </p:txBody>
+      </p:sp>
+      <p:sp>
+        <p:nvSpPr>
+          <p:cNvPr id="6" name="TextBox 5"/>
+          <p:cNvSpPr txBox="1"/>
+          <p:nvPr/>
+        </p:nvSpPr>
+        <p:spPr>
+          <a:xfrm>
+            <a:off x="548640" y="4206240"/>
+            <a:ext cx="8229600" cy="731520"/>
+          </a:xfrm>
+          <a:prstGeom prst="rect">
+            <a:avLst/>
+          </a:prstGeom>
+          <a:noFill/>
+        </p:spPr>
+        <p:txBody>
+          <a:bodyPr wrap="square">
+            <a:spAutoFit/>
+          </a:bodyPr>
+          <a:lstStyle/>
+          <a:p>
+            <a:pPr algn="l"/>
+            <a:r>
+              <a:rPr sz="2000" b="0">
+                <a:solidFill>
+                  <a:srgbClr val="B8C0CC"/>
+                </a:solidFill>
+                <a:latin typeface="Calibri"/>
+              </a:rPr>
+              <a:t>La huella digital del escritor</a:t>
+            </a:r>
+          </a:p>
+        </p:txBody>
+      </p:sp>
+    </p:spTree>
+  </p:cSld>
+  <p:clrMapOvr>
+    <a:masterClrMapping/>
+  </p:clrMapOvr>
+</p:sld>
+</file>
+
+<file path=ppt/slides/slide15.xml><?xml version="1.0" encoding="utf-8"?>
 <p:sld xmlns:a="http://schemas.openxmlformats.org/drawingml/2006/main" xmlns:p="http://schemas.openxmlformats.org/presentationml/2006/main" xmlns:r="http://schemas.openxmlformats.org/officeDocument/2006/relationships">
   <p:cSld>
     <p:bg>
@@ -5069,7 +5268,7 @@
                 </a:solidFill>
                 <a:latin typeface="Calibri"/>
               </a:rPr>
-              <a:t>Convergencia de señales — el principio de atribución</a:t>
+              <a:t>Burrows' Delta — el estándar de atribución de autoría</a:t>
             </a:r>
           </a:p>
         </p:txBody>
@@ -5104,7 +5303,7 @@
                 </a:solidFill>
                 <a:latin typeface="Calibri"/>
               </a:rPr>
-              <a:t>▸  Ninguna señal sola es evidencia de identidad — la convergencia sí lo es</a:t>
+              <a:t>▸  Mide la distribución de frecuencias de las N palabras más comunes, normalizada por z-score</a:t>
             </a:r>
           </a:p>
           <a:p>
@@ -5116,7 +5315,7 @@
                 </a:solidFill>
                 <a:latin typeface="Calibri"/>
               </a:rPr>
-              <a:t>▸  Handle exacto o fuzzy: fácil de cambiar, pero mucha gente no lo hace</a:t>
+              <a:t>▸  Esas palabras son las 'funcionales': artículos, preposiciones, conjunciones — difíciles de suprimir</a:t>
             </a:r>
           </a:p>
           <a:p>
@@ -5128,7 +5327,7 @@
                 </a:solidFill>
                 <a:latin typeface="Calibri"/>
               </a:rPr>
-              <a:t>▸  Similitud coseno de embeddings: captura estilo aunque cambie el vocabulario deliberadamente</a:t>
+              <a:t>▸  Delta bajo entre dos textos → mismo perfil de frecuencias → mismo autor probable</a:t>
             </a:r>
           </a:p>
           <a:p>
@@ -5140,7 +5339,7 @@
                 </a:solidFill>
                 <a:latin typeface="Calibri"/>
               </a:rPr>
-              <a:t>▸  Burrows' Delta: captura palabras función que el autor no controla conscientemente</a:t>
+              <a:t>▸  No depende del tema — solo del estilo de escritura</a:t>
             </a:r>
           </a:p>
           <a:p>
@@ -5152,7 +5351,7 @@
                 </a:solidFill>
                 <a:latin typeface="Calibri"/>
               </a:rPr>
-              <a:t>▸  Análisis temporal: el timezone real es muy difícil de falsificar de forma consistente</a:t>
+              <a:t>▸  Limitación: en corpus ideológicamente homogéneo el poder discriminante baja (vocabulario compartido)</a:t>
             </a:r>
           </a:p>
           <a:p>
@@ -5164,7 +5363,7 @@
                 </a:solidFill>
                 <a:latin typeface="Calibri"/>
               </a:rPr>
-              <a:t>▸  Regla práctica: ≥3 señales convergentes → candidato que merece investigación</a:t>
+              <a:t>▸  Complementar siempre con señales independientes: temporal, red, handle matching</a:t>
             </a:r>
           </a:p>
         </p:txBody>
@@ -5177,7 +5376,206 @@
 </p:sld>
 </file>
 
-<file path=ppt/slides/slide15.xml><?xml version="1.0" encoding="utf-8"?>
+<file path=ppt/slides/slide16.xml><?xml version="1.0" encoding="utf-8"?>
+<p:sld xmlns:a="http://schemas.openxmlformats.org/drawingml/2006/main" xmlns:p="http://schemas.openxmlformats.org/presentationml/2006/main" xmlns:r="http://schemas.openxmlformats.org/officeDocument/2006/relationships">
+  <p:cSld>
+    <p:bg>
+      <p:bgPr>
+        <a:solidFill>
+          <a:srgbClr val="1A1A2E"/>
+        </a:solidFill>
+        <a:effectLst/>
+      </p:bgPr>
+    </p:bg>
+    <p:spTree>
+      <p:nvGrpSpPr>
+        <p:cNvPr id="1" name=""/>
+        <p:cNvGrpSpPr/>
+        <p:nvPr/>
+      </p:nvGrpSpPr>
+      <p:grpSpPr/>
+      <p:sp>
+        <p:nvSpPr>
+          <p:cNvPr id="2" name="Rectangle 1"/>
+          <p:cNvSpPr/>
+          <p:nvPr/>
+        </p:nvSpPr>
+        <p:spPr>
+          <a:xfrm>
+            <a:off x="548640" y="1097280"/>
+            <a:ext cx="10515600" cy="27432"/>
+          </a:xfrm>
+          <a:prstGeom prst="rect">
+            <a:avLst/>
+          </a:prstGeom>
+          <a:solidFill>
+            <a:srgbClr val="E94E4E"/>
+          </a:solidFill>
+          <a:ln>
+            <a:noFill/>
+          </a:ln>
+        </p:spPr>
+        <p:style>
+          <a:lnRef idx="1">
+            <a:schemeClr val="accent1"/>
+          </a:lnRef>
+          <a:fillRef idx="3">
+            <a:schemeClr val="accent1"/>
+          </a:fillRef>
+          <a:effectRef idx="2">
+            <a:schemeClr val="accent1"/>
+          </a:effectRef>
+          <a:fontRef idx="minor">
+            <a:schemeClr val="lt1"/>
+          </a:fontRef>
+        </p:style>
+        <p:txBody>
+          <a:bodyPr rtlCol="0" anchor="ctr"/>
+          <a:lstStyle/>
+          <a:p>
+            <a:pPr algn="ctr"/>
+          </a:p>
+        </p:txBody>
+      </p:sp>
+      <p:sp>
+        <p:nvSpPr>
+          <p:cNvPr id="3" name="TextBox 2"/>
+          <p:cNvSpPr txBox="1"/>
+          <p:nvPr/>
+        </p:nvSpPr>
+        <p:spPr>
+          <a:xfrm>
+            <a:off x="548640" y="320040"/>
+            <a:ext cx="11064240" cy="822960"/>
+          </a:xfrm>
+          <a:prstGeom prst="rect">
+            <a:avLst/>
+          </a:prstGeom>
+          <a:noFill/>
+        </p:spPr>
+        <p:txBody>
+          <a:bodyPr wrap="square">
+            <a:spAutoFit/>
+          </a:bodyPr>
+          <a:lstStyle/>
+          <a:p>
+            <a:pPr algn="l"/>
+            <a:r>
+              <a:rPr sz="3200" b="1">
+                <a:solidFill>
+                  <a:srgbClr val="FFFFFF"/>
+                </a:solidFill>
+                <a:latin typeface="Calibri"/>
+              </a:rPr>
+              <a:t>Convergencia de señales — el principio de atribución</a:t>
+            </a:r>
+          </a:p>
+        </p:txBody>
+      </p:sp>
+      <p:sp>
+        <p:nvSpPr>
+          <p:cNvPr id="4" name="TextBox 3"/>
+          <p:cNvSpPr txBox="1"/>
+          <p:nvPr/>
+        </p:nvSpPr>
+        <p:spPr>
+          <a:xfrm>
+            <a:off x="548640" y="1371600"/>
+            <a:ext cx="11064240" cy="5029200"/>
+          </a:xfrm>
+          <a:prstGeom prst="rect">
+            <a:avLst/>
+          </a:prstGeom>
+          <a:noFill/>
+        </p:spPr>
+        <p:txBody>
+          <a:bodyPr wrap="square">
+            <a:spAutoFit/>
+          </a:bodyPr>
+          <a:lstStyle/>
+          <a:p>
+            <a:pPr algn="l" marL="0" indent="-228600"/>
+            <a:r>
+              <a:rPr sz="2000" b="0">
+                <a:solidFill>
+                  <a:srgbClr val="B8C0CC"/>
+                </a:solidFill>
+                <a:latin typeface="Calibri"/>
+              </a:rPr>
+              <a:t>▸  Ninguna señal sola es evidencia de identidad — la convergencia sí lo es</a:t>
+            </a:r>
+          </a:p>
+          <a:p>
+            <a:pPr algn="l" marL="0" indent="-228600"/>
+            <a:r>
+              <a:rPr sz="2000" b="0">
+                <a:solidFill>
+                  <a:srgbClr val="B8C0CC"/>
+                </a:solidFill>
+                <a:latin typeface="Calibri"/>
+              </a:rPr>
+              <a:t>▸  Handle exacto o fuzzy: fácil de cambiar, pero mucha gente no lo hace</a:t>
+            </a:r>
+          </a:p>
+          <a:p>
+            <a:pPr algn="l" marL="0" indent="-228600"/>
+            <a:r>
+              <a:rPr sz="2000" b="0">
+                <a:solidFill>
+                  <a:srgbClr val="B8C0CC"/>
+                </a:solidFill>
+                <a:latin typeface="Calibri"/>
+              </a:rPr>
+              <a:t>▸  Similitud coseno de embeddings: captura estilo aunque cambie el vocabulario deliberadamente</a:t>
+            </a:r>
+          </a:p>
+          <a:p>
+            <a:pPr algn="l" marL="0" indent="-228600"/>
+            <a:r>
+              <a:rPr sz="2000" b="0">
+                <a:solidFill>
+                  <a:srgbClr val="B8C0CC"/>
+                </a:solidFill>
+                <a:latin typeface="Calibri"/>
+              </a:rPr>
+              <a:t>▸  Burrows' Delta: captura palabras función que el autor no controla conscientemente</a:t>
+            </a:r>
+          </a:p>
+          <a:p>
+            <a:pPr algn="l" marL="0" indent="-228600"/>
+            <a:r>
+              <a:rPr sz="2000" b="0">
+                <a:solidFill>
+                  <a:srgbClr val="B8C0CC"/>
+                </a:solidFill>
+                <a:latin typeface="Calibri"/>
+              </a:rPr>
+              <a:t>▸  Análisis temporal: el timezone real es muy difícil de falsificar de forma consistente</a:t>
+            </a:r>
+          </a:p>
+          <a:p>
+            <a:pPr algn="l" marL="0" indent="-228600"/>
+            <a:r>
+              <a:rPr sz="2000" b="0">
+                <a:solidFill>
+                  <a:srgbClr val="B8C0CC"/>
+                </a:solidFill>
+                <a:latin typeface="Calibri"/>
+              </a:rPr>
+              <a:t>▸  Regla práctica: ≥3 señales convergentes → candidato que merece investigación</a:t>
+            </a:r>
+          </a:p>
+        </p:txBody>
+      </p:sp>
+    </p:spTree>
+  </p:cSld>
+  <p:clrMapOvr>
+    <a:masterClrMapping/>
+  </p:clrMapOvr>
+</p:sld>
+</file>
+
+<file path=ppt/slides/slide17.xml><?xml version="1.0" encoding="utf-8"?>
 <p:sld xmlns:a="http://schemas.openxmlformats.org/drawingml/2006/main" xmlns:p="http://schemas.openxmlformats.org/presentationml/2006/main" xmlns:r="http://schemas.openxmlformats.org/officeDocument/2006/relationships">
   <p:cSld>
     <p:bg>
@@ -6722,7 +7120,7 @@
     <p:bg>
       <p:bgPr>
         <a:solidFill>
-          <a:srgbClr val="0F0F20"/>
+          <a:srgbClr val="1A1A2E"/>
         </a:solidFill>
         <a:effectLst/>
       </p:bgPr>
@@ -6742,8 +7140,8 @@
         </p:nvSpPr>
         <p:spPr>
           <a:xfrm>
-            <a:off x="0" y="0"/>
-            <a:ext cx="12188952" cy="91440"/>
+            <a:off x="548640" y="1097280"/>
+            <a:ext cx="10515600" cy="27432"/>
           </a:xfrm>
           <a:prstGeom prst="rect">
             <a:avLst/>
@@ -6785,43 +7183,8 @@
         </p:nvSpPr>
         <p:spPr>
           <a:xfrm>
-            <a:off x="8686800" y="731520"/>
-            <a:ext cx="3200400" cy="4572000"/>
-          </a:xfrm>
-          <a:prstGeom prst="rect">
-            <a:avLst/>
-          </a:prstGeom>
-          <a:noFill/>
-        </p:spPr>
-        <p:txBody>
-          <a:bodyPr wrap="square">
-            <a:spAutoFit/>
-          </a:bodyPr>
-          <a:lstStyle/>
-          <a:p>
-            <a:pPr algn="r"/>
-            <a:r>
-              <a:rPr sz="20000" b="1">
-                <a:solidFill>
-                  <a:srgbClr val="252545"/>
-                </a:solidFill>
-                <a:latin typeface="Calibri"/>
-              </a:rPr>
-              <a:t>3</a:t>
-            </a:r>
-          </a:p>
-        </p:txBody>
-      </p:sp>
-      <p:sp>
-        <p:nvSpPr>
-          <p:cNvPr id="4" name="TextBox 3"/>
-          <p:cNvSpPr txBox="1"/>
-          <p:nvPr/>
-        </p:nvSpPr>
-        <p:spPr>
-          <a:xfrm>
-            <a:off x="548640" y="2011680"/>
-            <a:ext cx="5486400" cy="457200"/>
+            <a:off x="548640" y="320040"/>
+            <a:ext cx="11064240" cy="822960"/>
           </a:xfrm>
           <a:prstGeom prst="rect">
             <a:avLst/>
@@ -6836,14 +7199,57 @@
           <a:p>
             <a:pPr algn="l"/>
             <a:r>
-              <a:rPr sz="1300" b="1">
-                <a:solidFill>
-                  <a:srgbClr val="E94E4E"/>
-                </a:solidFill>
-                <a:latin typeface="Calibri"/>
-              </a:rPr>
-              <a:t>SECCIÓN</a:t>
-            </a:r>
+              <a:rPr sz="3200" b="1">
+                <a:solidFill>
+                  <a:srgbClr val="FFFFFF"/>
+                </a:solidFill>
+                <a:latin typeface="Calibri"/>
+              </a:rPr>
+              <a:t>¿Cuántos posts embedear por usuario? — comparativa de estrategias</a:t>
+            </a:r>
+          </a:p>
+        </p:txBody>
+      </p:sp>
+      <p:sp>
+        <p:nvSpPr>
+          <p:cNvPr id="4" name="Rectangle 3"/>
+          <p:cNvSpPr/>
+          <p:nvPr/>
+        </p:nvSpPr>
+        <p:spPr>
+          <a:xfrm>
+            <a:off x="548640" y="1325880"/>
+            <a:ext cx="10515600" cy="438912"/>
+          </a:xfrm>
+          <a:prstGeom prst="rect">
+            <a:avLst/>
+          </a:prstGeom>
+          <a:solidFill>
+            <a:srgbClr val="E94E4E"/>
+          </a:solidFill>
+          <a:ln>
+            <a:noFill/>
+          </a:ln>
+        </p:spPr>
+        <p:style>
+          <a:lnRef idx="1">
+            <a:schemeClr val="accent1"/>
+          </a:lnRef>
+          <a:fillRef idx="3">
+            <a:schemeClr val="accent1"/>
+          </a:fillRef>
+          <a:effectRef idx="2">
+            <a:schemeClr val="accent1"/>
+          </a:effectRef>
+          <a:fontRef idx="minor">
+            <a:schemeClr val="lt1"/>
+          </a:fontRef>
+        </p:style>
+        <p:txBody>
+          <a:bodyPr rtlCol="0" anchor="ctr"/>
+          <a:lstStyle/>
+          <a:p>
+            <a:pPr algn="ctr"/>
           </a:p>
         </p:txBody>
       </p:sp>
@@ -6855,8 +7261,8 @@
         </p:nvSpPr>
         <p:spPr>
           <a:xfrm>
-            <a:off x="548640" y="2468880"/>
-            <a:ext cx="8229600" cy="1645920"/>
+            <a:off x="594360" y="1385880"/>
+            <a:ext cx="2011680" cy="438912"/>
           </a:xfrm>
           <a:prstGeom prst="rect">
             <a:avLst/>
@@ -6871,13 +7277,13 @@
           <a:p>
             <a:pPr algn="l"/>
             <a:r>
-              <a:rPr sz="4000" b="1">
+              <a:rPr sz="1400" b="1">
                 <a:solidFill>
                   <a:srgbClr val="FFFFFF"/>
                 </a:solidFill>
                 <a:latin typeface="Calibri"/>
               </a:rPr>
-              <a:t>LLMs locales y NER en dominio específico</a:t>
+              <a:t>Estrategia</a:t>
             </a:r>
           </a:p>
         </p:txBody>
@@ -6890,8 +7296,8 @@
         </p:nvSpPr>
         <p:spPr>
           <a:xfrm>
-            <a:off x="548640" y="4206240"/>
-            <a:ext cx="8229600" cy="731520"/>
+            <a:off x="2697480" y="1385880"/>
+            <a:ext cx="2011680" cy="438912"/>
           </a:xfrm>
           <a:prstGeom prst="rect">
             <a:avLst/>
@@ -6906,13 +7312,1243 @@
           <a:p>
             <a:pPr algn="l"/>
             <a:r>
-              <a:rPr sz="2000" b="0">
-                <a:solidFill>
-                  <a:srgbClr val="B8C0CC"/>
-                </a:solidFill>
-                <a:latin typeface="Calibri"/>
-              </a:rPr>
-              <a:t>Privacidad no negociable con datos sensibles</a:t>
+              <a:rPr sz="1400" b="1">
+                <a:solidFill>
+                  <a:srgbClr val="FFFFFF"/>
+                </a:solidFill>
+                <a:latin typeface="Calibri"/>
+              </a:rPr>
+              <a:t>Posts por usuario</a:t>
+            </a:r>
+          </a:p>
+        </p:txBody>
+      </p:sp>
+      <p:sp>
+        <p:nvSpPr>
+          <p:cNvPr id="7" name="TextBox 6"/>
+          <p:cNvSpPr txBox="1"/>
+          <p:nvPr/>
+        </p:nvSpPr>
+        <p:spPr>
+          <a:xfrm>
+            <a:off x="4800600" y="1385880"/>
+            <a:ext cx="2011680" cy="438912"/>
+          </a:xfrm>
+          <a:prstGeom prst="rect">
+            <a:avLst/>
+          </a:prstGeom>
+          <a:noFill/>
+        </p:spPr>
+        <p:txBody>
+          <a:bodyPr wrap="square">
+            <a:spAutoFit/>
+          </a:bodyPr>
+          <a:lstStyle/>
+          <a:p>
+            <a:pPr algn="l"/>
+            <a:r>
+              <a:rPr sz="1400" b="1">
+                <a:solidFill>
+                  <a:srgbClr val="FFFFFF"/>
+                </a:solidFill>
+                <a:latin typeface="Calibri"/>
+              </a:rPr>
+              <a:t>GPU (IronMarch)</a:t>
+            </a:r>
+          </a:p>
+        </p:txBody>
+      </p:sp>
+      <p:sp>
+        <p:nvSpPr>
+          <p:cNvPr id="8" name="TextBox 7"/>
+          <p:cNvSpPr txBox="1"/>
+          <p:nvPr/>
+        </p:nvSpPr>
+        <p:spPr>
+          <a:xfrm>
+            <a:off x="6903720" y="1385880"/>
+            <a:ext cx="2011680" cy="438912"/>
+          </a:xfrm>
+          <a:prstGeom prst="rect">
+            <a:avLst/>
+          </a:prstGeom>
+          <a:noFill/>
+        </p:spPr>
+        <p:txBody>
+          <a:bodyPr wrap="square">
+            <a:spAutoFit/>
+          </a:bodyPr>
+          <a:lstStyle/>
+          <a:p>
+            <a:pPr algn="l"/>
+            <a:r>
+              <a:rPr sz="1400" b="1">
+                <a:solidFill>
+                  <a:srgbClr val="FFFFFF"/>
+                </a:solidFill>
+                <a:latin typeface="Calibri"/>
+              </a:rPr>
+              <a:t>Spearman ρ vs. full</a:t>
+            </a:r>
+          </a:p>
+        </p:txBody>
+      </p:sp>
+      <p:sp>
+        <p:nvSpPr>
+          <p:cNvPr id="9" name="TextBox 8"/>
+          <p:cNvSpPr txBox="1"/>
+          <p:nvPr/>
+        </p:nvSpPr>
+        <p:spPr>
+          <a:xfrm>
+            <a:off x="9006840" y="1385880"/>
+            <a:ext cx="2011680" cy="438912"/>
+          </a:xfrm>
+          <a:prstGeom prst="rect">
+            <a:avLst/>
+          </a:prstGeom>
+          <a:noFill/>
+        </p:spPr>
+        <p:txBody>
+          <a:bodyPr wrap="square">
+            <a:spAutoFit/>
+          </a:bodyPr>
+          <a:lstStyle/>
+          <a:p>
+            <a:pPr algn="l"/>
+            <a:r>
+              <a:rPr sz="1400" b="1">
+                <a:solidFill>
+                  <a:srgbClr val="FFFFFF"/>
+                </a:solidFill>
+                <a:latin typeface="Calibri"/>
+              </a:rPr>
+              <a:t>Cuándo usarla</a:t>
+            </a:r>
+          </a:p>
+        </p:txBody>
+      </p:sp>
+      <p:sp>
+        <p:nvSpPr>
+          <p:cNvPr id="10" name="Rectangle 9"/>
+          <p:cNvSpPr/>
+          <p:nvPr/>
+        </p:nvSpPr>
+        <p:spPr>
+          <a:xfrm>
+            <a:off x="548640" y="1764792"/>
+            <a:ext cx="10515600" cy="438912"/>
+          </a:xfrm>
+          <a:prstGeom prst="rect">
+            <a:avLst/>
+          </a:prstGeom>
+          <a:solidFill>
+            <a:srgbClr val="222240"/>
+          </a:solidFill>
+          <a:ln>
+            <a:noFill/>
+          </a:ln>
+        </p:spPr>
+        <p:style>
+          <a:lnRef idx="1">
+            <a:schemeClr val="accent1"/>
+          </a:lnRef>
+          <a:fillRef idx="3">
+            <a:schemeClr val="accent1"/>
+          </a:fillRef>
+          <a:effectRef idx="2">
+            <a:schemeClr val="accent1"/>
+          </a:effectRef>
+          <a:fontRef idx="minor">
+            <a:schemeClr val="lt1"/>
+          </a:fontRef>
+        </p:style>
+        <p:txBody>
+          <a:bodyPr rtlCol="0" anchor="ctr"/>
+          <a:lstStyle/>
+          <a:p>
+            <a:pPr algn="ctr"/>
+          </a:p>
+        </p:txBody>
+      </p:sp>
+      <p:sp>
+        <p:nvSpPr>
+          <p:cNvPr id="11" name="TextBox 10"/>
+          <p:cNvSpPr txBox="1"/>
+          <p:nvPr/>
+        </p:nvSpPr>
+        <p:spPr>
+          <a:xfrm>
+            <a:off x="594360" y="1814792"/>
+            <a:ext cx="2011680" cy="438912"/>
+          </a:xfrm>
+          <a:prstGeom prst="rect">
+            <a:avLst/>
+          </a:prstGeom>
+          <a:noFill/>
+        </p:spPr>
+        <p:txBody>
+          <a:bodyPr wrap="square">
+            <a:spAutoFit/>
+          </a:bodyPr>
+          <a:lstStyle/>
+          <a:p>
+            <a:pPr algn="l"/>
+            <a:r>
+              <a:rPr sz="1300" b="0">
+                <a:solidFill>
+                  <a:srgbClr val="B8C0CC"/>
+                </a:solidFill>
+                <a:latin typeface="Calibri"/>
+              </a:rPr>
+              <a:t>A — concat todo</a:t>
+            </a:r>
+          </a:p>
+        </p:txBody>
+      </p:sp>
+      <p:sp>
+        <p:nvSpPr>
+          <p:cNvPr id="12" name="TextBox 11"/>
+          <p:cNvSpPr txBox="1"/>
+          <p:nvPr/>
+        </p:nvSpPr>
+        <p:spPr>
+          <a:xfrm>
+            <a:off x="2697480" y="1814792"/>
+            <a:ext cx="2011680" cy="438912"/>
+          </a:xfrm>
+          <a:prstGeom prst="rect">
+            <a:avLst/>
+          </a:prstGeom>
+          <a:noFill/>
+        </p:spPr>
+        <p:txBody>
+          <a:bodyPr wrap="square">
+            <a:spAutoFit/>
+          </a:bodyPr>
+          <a:lstStyle/>
+          <a:p>
+            <a:pPr algn="l"/>
+            <a:r>
+              <a:rPr sz="1300" b="0">
+                <a:solidFill>
+                  <a:srgbClr val="B8C0CC"/>
+                </a:solidFill>
+                <a:latin typeface="Calibri"/>
+              </a:rPr>
+              <a:t>todos (máx. 50K chars)</a:t>
+            </a:r>
+          </a:p>
+        </p:txBody>
+      </p:sp>
+      <p:sp>
+        <p:nvSpPr>
+          <p:cNvPr id="13" name="TextBox 12"/>
+          <p:cNvSpPr txBox="1"/>
+          <p:nvPr/>
+        </p:nvSpPr>
+        <p:spPr>
+          <a:xfrm>
+            <a:off x="4800600" y="1814792"/>
+            <a:ext cx="2011680" cy="438912"/>
+          </a:xfrm>
+          <a:prstGeom prst="rect">
+            <a:avLst/>
+          </a:prstGeom>
+          <a:noFill/>
+        </p:spPr>
+        <p:txBody>
+          <a:bodyPr wrap="square">
+            <a:spAutoFit/>
+          </a:bodyPr>
+          <a:lstStyle/>
+          <a:p>
+            <a:pPr algn="l"/>
+            <a:r>
+              <a:rPr sz="1300" b="0">
+                <a:solidFill>
+                  <a:srgbClr val="B8C0CC"/>
+                </a:solidFill>
+                <a:latin typeface="Calibri"/>
+              </a:rPr>
+              <a:t>~12 min</a:t>
+            </a:r>
+          </a:p>
+        </p:txBody>
+      </p:sp>
+      <p:sp>
+        <p:nvSpPr>
+          <p:cNvPr id="14" name="TextBox 13"/>
+          <p:cNvSpPr txBox="1"/>
+          <p:nvPr/>
+        </p:nvSpPr>
+        <p:spPr>
+          <a:xfrm>
+            <a:off x="6903720" y="1814792"/>
+            <a:ext cx="2011680" cy="438912"/>
+          </a:xfrm>
+          <a:prstGeom prst="rect">
+            <a:avLst/>
+          </a:prstGeom>
+          <a:noFill/>
+        </p:spPr>
+        <p:txBody>
+          <a:bodyPr wrap="square">
+            <a:spAutoFit/>
+          </a:bodyPr>
+          <a:lstStyle/>
+          <a:p>
+            <a:pPr algn="l"/>
+            <a:r>
+              <a:rPr sz="1300" b="0">
+                <a:solidFill>
+                  <a:srgbClr val="B8C0CC"/>
+                </a:solidFill>
+                <a:latin typeface="Calibri"/>
+              </a:rPr>
+              <a:t>—</a:t>
+            </a:r>
+          </a:p>
+        </p:txBody>
+      </p:sp>
+      <p:sp>
+        <p:nvSpPr>
+          <p:cNvPr id="15" name="TextBox 14"/>
+          <p:cNvSpPr txBox="1"/>
+          <p:nvPr/>
+        </p:nvSpPr>
+        <p:spPr>
+          <a:xfrm>
+            <a:off x="9006840" y="1814792"/>
+            <a:ext cx="2011680" cy="438912"/>
+          </a:xfrm>
+          <a:prstGeom prst="rect">
+            <a:avLst/>
+          </a:prstGeom>
+          <a:noFill/>
+        </p:spPr>
+        <p:txBody>
+          <a:bodyPr wrap="square">
+            <a:spAutoFit/>
+          </a:bodyPr>
+          <a:lstStyle/>
+          <a:p>
+            <a:pPr algn="l"/>
+            <a:r>
+              <a:rPr sz="1300" b="0">
+                <a:solidFill>
+                  <a:srgbClr val="B8C0CC"/>
+                </a:solidFill>
+                <a:latin typeface="Calibri"/>
+              </a:rPr>
+              <a:t>Dataset pequeño o usuarios con pocos posts</a:t>
+            </a:r>
+          </a:p>
+        </p:txBody>
+      </p:sp>
+      <p:sp>
+        <p:nvSpPr>
+          <p:cNvPr id="16" name="Rectangle 15"/>
+          <p:cNvSpPr/>
+          <p:nvPr/>
+        </p:nvSpPr>
+        <p:spPr>
+          <a:xfrm>
+            <a:off x="548640" y="2203704"/>
+            <a:ext cx="10515600" cy="438912"/>
+          </a:xfrm>
+          <a:prstGeom prst="rect">
+            <a:avLst/>
+          </a:prstGeom>
+          <a:solidFill>
+            <a:srgbClr val="1E1E38"/>
+          </a:solidFill>
+          <a:ln>
+            <a:noFill/>
+          </a:ln>
+        </p:spPr>
+        <p:style>
+          <a:lnRef idx="1">
+            <a:schemeClr val="accent1"/>
+          </a:lnRef>
+          <a:fillRef idx="3">
+            <a:schemeClr val="accent1"/>
+          </a:fillRef>
+          <a:effectRef idx="2">
+            <a:schemeClr val="accent1"/>
+          </a:effectRef>
+          <a:fontRef idx="minor">
+            <a:schemeClr val="lt1"/>
+          </a:fontRef>
+        </p:style>
+        <p:txBody>
+          <a:bodyPr rtlCol="0" anchor="ctr"/>
+          <a:lstStyle/>
+          <a:p>
+            <a:pPr algn="ctr"/>
+          </a:p>
+        </p:txBody>
+      </p:sp>
+      <p:sp>
+        <p:nvSpPr>
+          <p:cNvPr id="17" name="TextBox 16"/>
+          <p:cNvSpPr txBox="1"/>
+          <p:nvPr/>
+        </p:nvSpPr>
+        <p:spPr>
+          <a:xfrm>
+            <a:off x="594360" y="2253704"/>
+            <a:ext cx="2011680" cy="438912"/>
+          </a:xfrm>
+          <a:prstGeom prst="rect">
+            <a:avLst/>
+          </a:prstGeom>
+          <a:noFill/>
+        </p:spPr>
+        <p:txBody>
+          <a:bodyPr wrap="square">
+            <a:spAutoFit/>
+          </a:bodyPr>
+          <a:lstStyle/>
+          <a:p>
+            <a:pPr algn="l"/>
+            <a:r>
+              <a:rPr sz="1300" b="0">
+                <a:solidFill>
+                  <a:srgbClr val="B8C0CC"/>
+                </a:solidFill>
+                <a:latin typeface="Calibri"/>
+              </a:rPr>
+              <a:t>B — full centroid</a:t>
+            </a:r>
+          </a:p>
+        </p:txBody>
+      </p:sp>
+      <p:sp>
+        <p:nvSpPr>
+          <p:cNvPr id="18" name="TextBox 17"/>
+          <p:cNvSpPr txBox="1"/>
+          <p:nvPr/>
+        </p:nvSpPr>
+        <p:spPr>
+          <a:xfrm>
+            <a:off x="2697480" y="2253704"/>
+            <a:ext cx="2011680" cy="438912"/>
+          </a:xfrm>
+          <a:prstGeom prst="rect">
+            <a:avLst/>
+          </a:prstGeom>
+          <a:noFill/>
+        </p:spPr>
+        <p:txBody>
+          <a:bodyPr wrap="square">
+            <a:spAutoFit/>
+          </a:bodyPr>
+          <a:lstStyle/>
+          <a:p>
+            <a:pPr algn="l"/>
+            <a:r>
+              <a:rPr sz="1300" b="0">
+                <a:solidFill>
+                  <a:srgbClr val="B8C0CC"/>
+                </a:solidFill>
+                <a:latin typeface="Calibri"/>
+              </a:rPr>
+              <a:t>todos</a:t>
+            </a:r>
+          </a:p>
+        </p:txBody>
+      </p:sp>
+      <p:sp>
+        <p:nvSpPr>
+          <p:cNvPr id="19" name="TextBox 18"/>
+          <p:cNvSpPr txBox="1"/>
+          <p:nvPr/>
+        </p:nvSpPr>
+        <p:spPr>
+          <a:xfrm>
+            <a:off x="4800600" y="2253704"/>
+            <a:ext cx="2011680" cy="438912"/>
+          </a:xfrm>
+          <a:prstGeom prst="rect">
+            <a:avLst/>
+          </a:prstGeom>
+          <a:noFill/>
+        </p:spPr>
+        <p:txBody>
+          <a:bodyPr wrap="square">
+            <a:spAutoFit/>
+          </a:bodyPr>
+          <a:lstStyle/>
+          <a:p>
+            <a:pPr algn="l"/>
+            <a:r>
+              <a:rPr sz="1300" b="0">
+                <a:solidFill>
+                  <a:srgbClr val="B8C0CC"/>
+                </a:solidFill>
+                <a:latin typeface="Calibri"/>
+              </a:rPr>
+              <a:t>~9 h</a:t>
+            </a:r>
+          </a:p>
+        </p:txBody>
+      </p:sp>
+      <p:sp>
+        <p:nvSpPr>
+          <p:cNvPr id="20" name="TextBox 19"/>
+          <p:cNvSpPr txBox="1"/>
+          <p:nvPr/>
+        </p:nvSpPr>
+        <p:spPr>
+          <a:xfrm>
+            <a:off x="6903720" y="2253704"/>
+            <a:ext cx="2011680" cy="438912"/>
+          </a:xfrm>
+          <a:prstGeom prst="rect">
+            <a:avLst/>
+          </a:prstGeom>
+          <a:noFill/>
+        </p:spPr>
+        <p:txBody>
+          <a:bodyPr wrap="square">
+            <a:spAutoFit/>
+          </a:bodyPr>
+          <a:lstStyle/>
+          <a:p>
+            <a:pPr algn="l"/>
+            <a:r>
+              <a:rPr sz="1300" b="0">
+                <a:solidFill>
+                  <a:srgbClr val="B8C0CC"/>
+                </a:solidFill>
+                <a:latin typeface="Calibri"/>
+              </a:rPr>
+              <a:t>1.000</a:t>
+            </a:r>
+          </a:p>
+        </p:txBody>
+      </p:sp>
+      <p:sp>
+        <p:nvSpPr>
+          <p:cNvPr id="21" name="TextBox 20"/>
+          <p:cNvSpPr txBox="1"/>
+          <p:nvPr/>
+        </p:nvSpPr>
+        <p:spPr>
+          <a:xfrm>
+            <a:off x="9006840" y="2253704"/>
+            <a:ext cx="2011680" cy="438912"/>
+          </a:xfrm>
+          <a:prstGeom prst="rect">
+            <a:avLst/>
+          </a:prstGeom>
+          <a:noFill/>
+        </p:spPr>
+        <p:txBody>
+          <a:bodyPr wrap="square">
+            <a:spAutoFit/>
+          </a:bodyPr>
+          <a:lstStyle/>
+          <a:p>
+            <a:pPr algn="l"/>
+            <a:r>
+              <a:rPr sz="1300" b="0">
+                <a:solidFill>
+                  <a:srgbClr val="B8C0CC"/>
+                </a:solidFill>
+                <a:latin typeface="Calibri"/>
+              </a:rPr>
+              <a:t>Solo como referencia — inviable en producción</a:t>
+            </a:r>
+          </a:p>
+        </p:txBody>
+      </p:sp>
+      <p:sp>
+        <p:nvSpPr>
+          <p:cNvPr id="22" name="Rectangle 21"/>
+          <p:cNvSpPr/>
+          <p:nvPr/>
+        </p:nvSpPr>
+        <p:spPr>
+          <a:xfrm>
+            <a:off x="548640" y="2642616"/>
+            <a:ext cx="10515600" cy="438912"/>
+          </a:xfrm>
+          <a:prstGeom prst="rect">
+            <a:avLst/>
+          </a:prstGeom>
+          <a:solidFill>
+            <a:srgbClr val="222240"/>
+          </a:solidFill>
+          <a:ln>
+            <a:noFill/>
+          </a:ln>
+        </p:spPr>
+        <p:style>
+          <a:lnRef idx="1">
+            <a:schemeClr val="accent1"/>
+          </a:lnRef>
+          <a:fillRef idx="3">
+            <a:schemeClr val="accent1"/>
+          </a:fillRef>
+          <a:effectRef idx="2">
+            <a:schemeClr val="accent1"/>
+          </a:effectRef>
+          <a:fontRef idx="minor">
+            <a:schemeClr val="lt1"/>
+          </a:fontRef>
+        </p:style>
+        <p:txBody>
+          <a:bodyPr rtlCol="0" anchor="ctr"/>
+          <a:lstStyle/>
+          <a:p>
+            <a:pPr algn="ctr"/>
+          </a:p>
+        </p:txBody>
+      </p:sp>
+      <p:sp>
+        <p:nvSpPr>
+          <p:cNvPr id="23" name="TextBox 22"/>
+          <p:cNvSpPr txBox="1"/>
+          <p:nvPr/>
+        </p:nvSpPr>
+        <p:spPr>
+          <a:xfrm>
+            <a:off x="594360" y="2692616"/>
+            <a:ext cx="2011680" cy="438912"/>
+          </a:xfrm>
+          <a:prstGeom prst="rect">
+            <a:avLst/>
+          </a:prstGeom>
+          <a:noFill/>
+        </p:spPr>
+        <p:txBody>
+          <a:bodyPr wrap="square">
+            <a:spAutoFit/>
+          </a:bodyPr>
+          <a:lstStyle/>
+          <a:p>
+            <a:pPr algn="l"/>
+            <a:r>
+              <a:rPr sz="1300" b="0">
+                <a:solidFill>
+                  <a:srgbClr val="B8C0CC"/>
+                </a:solidFill>
+                <a:latin typeface="Calibri"/>
+              </a:rPr>
+              <a:t>C — top-50</a:t>
+            </a:r>
+          </a:p>
+        </p:txBody>
+      </p:sp>
+      <p:sp>
+        <p:nvSpPr>
+          <p:cNvPr id="24" name="TextBox 23"/>
+          <p:cNvSpPr txBox="1"/>
+          <p:nvPr/>
+        </p:nvSpPr>
+        <p:spPr>
+          <a:xfrm>
+            <a:off x="2697480" y="2692616"/>
+            <a:ext cx="2011680" cy="438912"/>
+          </a:xfrm>
+          <a:prstGeom prst="rect">
+            <a:avLst/>
+          </a:prstGeom>
+          <a:noFill/>
+        </p:spPr>
+        <p:txBody>
+          <a:bodyPr wrap="square">
+            <a:spAutoFit/>
+          </a:bodyPr>
+          <a:lstStyle/>
+          <a:p>
+            <a:pPr algn="l"/>
+            <a:r>
+              <a:rPr sz="1300" b="0">
+                <a:solidFill>
+                  <a:srgbClr val="B8C0CC"/>
+                </a:solidFill>
+                <a:latin typeface="Calibri"/>
+              </a:rPr>
+              <a:t>50 más largos</a:t>
+            </a:r>
+          </a:p>
+        </p:txBody>
+      </p:sp>
+      <p:sp>
+        <p:nvSpPr>
+          <p:cNvPr id="25" name="TextBox 24"/>
+          <p:cNvSpPr txBox="1"/>
+          <p:nvPr/>
+        </p:nvSpPr>
+        <p:spPr>
+          <a:xfrm>
+            <a:off x="4800600" y="2692616"/>
+            <a:ext cx="2011680" cy="438912"/>
+          </a:xfrm>
+          <a:prstGeom prst="rect">
+            <a:avLst/>
+          </a:prstGeom>
+          <a:noFill/>
+        </p:spPr>
+        <p:txBody>
+          <a:bodyPr wrap="square">
+            <a:spAutoFit/>
+          </a:bodyPr>
+          <a:lstStyle/>
+          <a:p>
+            <a:pPr algn="l"/>
+            <a:r>
+              <a:rPr sz="1300" b="0">
+                <a:solidFill>
+                  <a:srgbClr val="B8C0CC"/>
+                </a:solidFill>
+                <a:latin typeface="Calibri"/>
+              </a:rPr>
+              <a:t>2h 35min</a:t>
+            </a:r>
+          </a:p>
+        </p:txBody>
+      </p:sp>
+      <p:sp>
+        <p:nvSpPr>
+          <p:cNvPr id="26" name="TextBox 25"/>
+          <p:cNvSpPr txBox="1"/>
+          <p:nvPr/>
+        </p:nvSpPr>
+        <p:spPr>
+          <a:xfrm>
+            <a:off x="6903720" y="2692616"/>
+            <a:ext cx="2011680" cy="438912"/>
+          </a:xfrm>
+          <a:prstGeom prst="rect">
+            <a:avLst/>
+          </a:prstGeom>
+          <a:noFill/>
+        </p:spPr>
+        <p:txBody>
+          <a:bodyPr wrap="square">
+            <a:spAutoFit/>
+          </a:bodyPr>
+          <a:lstStyle/>
+          <a:p>
+            <a:pPr algn="l"/>
+            <a:r>
+              <a:rPr sz="1300" b="0">
+                <a:solidFill>
+                  <a:srgbClr val="B8C0CC"/>
+                </a:solidFill>
+                <a:latin typeface="Calibri"/>
+              </a:rPr>
+              <a:t>0.799</a:t>
+            </a:r>
+          </a:p>
+        </p:txBody>
+      </p:sp>
+      <p:sp>
+        <p:nvSpPr>
+          <p:cNvPr id="27" name="TextBox 26"/>
+          <p:cNvSpPr txBox="1"/>
+          <p:nvPr/>
+        </p:nvSpPr>
+        <p:spPr>
+          <a:xfrm>
+            <a:off x="9006840" y="2692616"/>
+            <a:ext cx="2011680" cy="438912"/>
+          </a:xfrm>
+          <a:prstGeom prst="rect">
+            <a:avLst/>
+          </a:prstGeom>
+          <a:noFill/>
+        </p:spPr>
+        <p:txBody>
+          <a:bodyPr wrap="square">
+            <a:spAutoFit/>
+          </a:bodyPr>
+          <a:lstStyle/>
+          <a:p>
+            <a:pPr algn="l"/>
+            <a:r>
+              <a:rPr sz="1300" b="0">
+                <a:solidFill>
+                  <a:srgbClr val="B8C0CC"/>
+                </a:solidFill>
+                <a:latin typeface="Calibri"/>
+              </a:rPr>
+              <a:t>GPU limitada o usuarios con &lt;100 posts típicos</a:t>
+            </a:r>
+          </a:p>
+        </p:txBody>
+      </p:sp>
+      <p:sp>
+        <p:nvSpPr>
+          <p:cNvPr id="28" name="Rectangle 27"/>
+          <p:cNvSpPr/>
+          <p:nvPr/>
+        </p:nvSpPr>
+        <p:spPr>
+          <a:xfrm>
+            <a:off x="548640" y="3081528"/>
+            <a:ext cx="10515600" cy="438912"/>
+          </a:xfrm>
+          <a:prstGeom prst="rect">
+            <a:avLst/>
+          </a:prstGeom>
+          <a:solidFill>
+            <a:srgbClr val="1E1E38"/>
+          </a:solidFill>
+          <a:ln>
+            <a:noFill/>
+          </a:ln>
+        </p:spPr>
+        <p:style>
+          <a:lnRef idx="1">
+            <a:schemeClr val="accent1"/>
+          </a:lnRef>
+          <a:fillRef idx="3">
+            <a:schemeClr val="accent1"/>
+          </a:fillRef>
+          <a:effectRef idx="2">
+            <a:schemeClr val="accent1"/>
+          </a:effectRef>
+          <a:fontRef idx="minor">
+            <a:schemeClr val="lt1"/>
+          </a:fontRef>
+        </p:style>
+        <p:txBody>
+          <a:bodyPr rtlCol="0" anchor="ctr"/>
+          <a:lstStyle/>
+          <a:p>
+            <a:pPr algn="ctr"/>
+          </a:p>
+        </p:txBody>
+      </p:sp>
+      <p:sp>
+        <p:nvSpPr>
+          <p:cNvPr id="29" name="TextBox 28"/>
+          <p:cNvSpPr txBox="1"/>
+          <p:nvPr/>
+        </p:nvSpPr>
+        <p:spPr>
+          <a:xfrm>
+            <a:off x="594360" y="3131528"/>
+            <a:ext cx="2011680" cy="438912"/>
+          </a:xfrm>
+          <a:prstGeom prst="rect">
+            <a:avLst/>
+          </a:prstGeom>
+          <a:noFill/>
+        </p:spPr>
+        <p:txBody>
+          <a:bodyPr wrap="square">
+            <a:spAutoFit/>
+          </a:bodyPr>
+          <a:lstStyle/>
+          <a:p>
+            <a:pPr algn="l"/>
+            <a:r>
+              <a:rPr sz="1300" b="0">
+                <a:solidFill>
+                  <a:srgbClr val="B8C0CC"/>
+                </a:solidFill>
+                <a:latin typeface="Calibri"/>
+              </a:rPr>
+              <a:t>D — top-100</a:t>
+            </a:r>
+          </a:p>
+        </p:txBody>
+      </p:sp>
+      <p:sp>
+        <p:nvSpPr>
+          <p:cNvPr id="30" name="TextBox 29"/>
+          <p:cNvSpPr txBox="1"/>
+          <p:nvPr/>
+        </p:nvSpPr>
+        <p:spPr>
+          <a:xfrm>
+            <a:off x="2697480" y="3131528"/>
+            <a:ext cx="2011680" cy="438912"/>
+          </a:xfrm>
+          <a:prstGeom prst="rect">
+            <a:avLst/>
+          </a:prstGeom>
+          <a:noFill/>
+        </p:spPr>
+        <p:txBody>
+          <a:bodyPr wrap="square">
+            <a:spAutoFit/>
+          </a:bodyPr>
+          <a:lstStyle/>
+          <a:p>
+            <a:pPr algn="l"/>
+            <a:r>
+              <a:rPr sz="1300" b="0">
+                <a:solidFill>
+                  <a:srgbClr val="B8C0CC"/>
+                </a:solidFill>
+                <a:latin typeface="Calibri"/>
+              </a:rPr>
+              <a:t>100 más largos</a:t>
+            </a:r>
+          </a:p>
+        </p:txBody>
+      </p:sp>
+      <p:sp>
+        <p:nvSpPr>
+          <p:cNvPr id="31" name="TextBox 30"/>
+          <p:cNvSpPr txBox="1"/>
+          <p:nvPr/>
+        </p:nvSpPr>
+        <p:spPr>
+          <a:xfrm>
+            <a:off x="4800600" y="3131528"/>
+            <a:ext cx="2011680" cy="438912"/>
+          </a:xfrm>
+          <a:prstGeom prst="rect">
+            <a:avLst/>
+          </a:prstGeom>
+          <a:noFill/>
+        </p:spPr>
+        <p:txBody>
+          <a:bodyPr wrap="square">
+            <a:spAutoFit/>
+          </a:bodyPr>
+          <a:lstStyle/>
+          <a:p>
+            <a:pPr algn="l"/>
+            <a:r>
+              <a:rPr sz="1300" b="0">
+                <a:solidFill>
+                  <a:srgbClr val="B8C0CC"/>
+                </a:solidFill>
+                <a:latin typeface="Calibri"/>
+              </a:rPr>
+              <a:t>3h 33min</a:t>
+            </a:r>
+          </a:p>
+        </p:txBody>
+      </p:sp>
+      <p:sp>
+        <p:nvSpPr>
+          <p:cNvPr id="32" name="TextBox 31"/>
+          <p:cNvSpPr txBox="1"/>
+          <p:nvPr/>
+        </p:nvSpPr>
+        <p:spPr>
+          <a:xfrm>
+            <a:off x="6903720" y="3131528"/>
+            <a:ext cx="2011680" cy="438912"/>
+          </a:xfrm>
+          <a:prstGeom prst="rect">
+            <a:avLst/>
+          </a:prstGeom>
+          <a:noFill/>
+        </p:spPr>
+        <p:txBody>
+          <a:bodyPr wrap="square">
+            <a:spAutoFit/>
+          </a:bodyPr>
+          <a:lstStyle/>
+          <a:p>
+            <a:pPr algn="l"/>
+            <a:r>
+              <a:rPr sz="1300" b="0">
+                <a:solidFill>
+                  <a:srgbClr val="B8C0CC"/>
+                </a:solidFill>
+                <a:latin typeface="Calibri"/>
+              </a:rPr>
+              <a:t>0.860</a:t>
+            </a:r>
+          </a:p>
+        </p:txBody>
+      </p:sp>
+      <p:sp>
+        <p:nvSpPr>
+          <p:cNvPr id="33" name="TextBox 32"/>
+          <p:cNvSpPr txBox="1"/>
+          <p:nvPr/>
+        </p:nvSpPr>
+        <p:spPr>
+          <a:xfrm>
+            <a:off x="9006840" y="3131528"/>
+            <a:ext cx="2011680" cy="438912"/>
+          </a:xfrm>
+          <a:prstGeom prst="rect">
+            <a:avLst/>
+          </a:prstGeom>
+          <a:noFill/>
+        </p:spPr>
+        <p:txBody>
+          <a:bodyPr wrap="square">
+            <a:spAutoFit/>
+          </a:bodyPr>
+          <a:lstStyle/>
+          <a:p>
+            <a:pPr algn="l"/>
+            <a:r>
+              <a:rPr sz="1300" b="0">
+                <a:solidFill>
+                  <a:srgbClr val="B8C0CC"/>
+                </a:solidFill>
+                <a:latin typeface="Calibri"/>
+              </a:rPr>
+              <a:t>Caso general — mejor ratio fidelidad/coste</a:t>
+            </a:r>
+          </a:p>
+        </p:txBody>
+      </p:sp>
+      <p:sp>
+        <p:nvSpPr>
+          <p:cNvPr id="34" name="Rectangle 33"/>
+          <p:cNvSpPr/>
+          <p:nvPr/>
+        </p:nvSpPr>
+        <p:spPr>
+          <a:xfrm>
+            <a:off x="548640" y="3520440"/>
+            <a:ext cx="10515600" cy="438912"/>
+          </a:xfrm>
+          <a:prstGeom prst="rect">
+            <a:avLst/>
+          </a:prstGeom>
+          <a:solidFill>
+            <a:srgbClr val="222240"/>
+          </a:solidFill>
+          <a:ln>
+            <a:noFill/>
+          </a:ln>
+        </p:spPr>
+        <p:style>
+          <a:lnRef idx="1">
+            <a:schemeClr val="accent1"/>
+          </a:lnRef>
+          <a:fillRef idx="3">
+            <a:schemeClr val="accent1"/>
+          </a:fillRef>
+          <a:effectRef idx="2">
+            <a:schemeClr val="accent1"/>
+          </a:effectRef>
+          <a:fontRef idx="minor">
+            <a:schemeClr val="lt1"/>
+          </a:fontRef>
+        </p:style>
+        <p:txBody>
+          <a:bodyPr rtlCol="0" anchor="ctr"/>
+          <a:lstStyle/>
+          <a:p>
+            <a:pPr algn="ctr"/>
+          </a:p>
+        </p:txBody>
+      </p:sp>
+      <p:sp>
+        <p:nvSpPr>
+          <p:cNvPr id="35" name="TextBox 34"/>
+          <p:cNvSpPr txBox="1"/>
+          <p:nvPr/>
+        </p:nvSpPr>
+        <p:spPr>
+          <a:xfrm>
+            <a:off x="594360" y="3570440"/>
+            <a:ext cx="2011680" cy="438912"/>
+          </a:xfrm>
+          <a:prstGeom prst="rect">
+            <a:avLst/>
+          </a:prstGeom>
+          <a:noFill/>
+        </p:spPr>
+        <p:txBody>
+          <a:bodyPr wrap="square">
+            <a:spAutoFit/>
+          </a:bodyPr>
+          <a:lstStyle/>
+          <a:p>
+            <a:pPr algn="l"/>
+            <a:r>
+              <a:rPr sz="1300" b="0">
+                <a:solidFill>
+                  <a:srgbClr val="B8C0CC"/>
+                </a:solidFill>
+                <a:latin typeface="Calibri"/>
+              </a:rPr>
+              <a:t>E — top-150</a:t>
+            </a:r>
+          </a:p>
+        </p:txBody>
+      </p:sp>
+      <p:sp>
+        <p:nvSpPr>
+          <p:cNvPr id="36" name="TextBox 35"/>
+          <p:cNvSpPr txBox="1"/>
+          <p:nvPr/>
+        </p:nvSpPr>
+        <p:spPr>
+          <a:xfrm>
+            <a:off x="2697480" y="3570440"/>
+            <a:ext cx="2011680" cy="438912"/>
+          </a:xfrm>
+          <a:prstGeom prst="rect">
+            <a:avLst/>
+          </a:prstGeom>
+          <a:noFill/>
+        </p:spPr>
+        <p:txBody>
+          <a:bodyPr wrap="square">
+            <a:spAutoFit/>
+          </a:bodyPr>
+          <a:lstStyle/>
+          <a:p>
+            <a:pPr algn="l"/>
+            <a:r>
+              <a:rPr sz="1300" b="0">
+                <a:solidFill>
+                  <a:srgbClr val="B8C0CC"/>
+                </a:solidFill>
+                <a:latin typeface="Calibri"/>
+              </a:rPr>
+              <a:t>150 más largos</a:t>
+            </a:r>
+          </a:p>
+        </p:txBody>
+      </p:sp>
+      <p:sp>
+        <p:nvSpPr>
+          <p:cNvPr id="37" name="TextBox 36"/>
+          <p:cNvSpPr txBox="1"/>
+          <p:nvPr/>
+        </p:nvSpPr>
+        <p:spPr>
+          <a:xfrm>
+            <a:off x="4800600" y="3570440"/>
+            <a:ext cx="2011680" cy="438912"/>
+          </a:xfrm>
+          <a:prstGeom prst="rect">
+            <a:avLst/>
+          </a:prstGeom>
+          <a:noFill/>
+        </p:spPr>
+        <p:txBody>
+          <a:bodyPr wrap="square">
+            <a:spAutoFit/>
+          </a:bodyPr>
+          <a:lstStyle/>
+          <a:p>
+            <a:pPr algn="l"/>
+            <a:r>
+              <a:rPr sz="1300" b="0">
+                <a:solidFill>
+                  <a:srgbClr val="B8C0CC"/>
+                </a:solidFill>
+                <a:latin typeface="Calibri"/>
+              </a:rPr>
+              <a:t>4h 12min</a:t>
+            </a:r>
+          </a:p>
+        </p:txBody>
+      </p:sp>
+      <p:sp>
+        <p:nvSpPr>
+          <p:cNvPr id="38" name="TextBox 37"/>
+          <p:cNvSpPr txBox="1"/>
+          <p:nvPr/>
+        </p:nvSpPr>
+        <p:spPr>
+          <a:xfrm>
+            <a:off x="6903720" y="3570440"/>
+            <a:ext cx="2011680" cy="438912"/>
+          </a:xfrm>
+          <a:prstGeom prst="rect">
+            <a:avLst/>
+          </a:prstGeom>
+          <a:noFill/>
+        </p:spPr>
+        <p:txBody>
+          <a:bodyPr wrap="square">
+            <a:spAutoFit/>
+          </a:bodyPr>
+          <a:lstStyle/>
+          <a:p>
+            <a:pPr algn="l"/>
+            <a:r>
+              <a:rPr sz="1300" b="0">
+                <a:solidFill>
+                  <a:srgbClr val="B8C0CC"/>
+                </a:solidFill>
+                <a:latin typeface="Calibri"/>
+              </a:rPr>
+              <a:t>0.896</a:t>
+            </a:r>
+          </a:p>
+        </p:txBody>
+      </p:sp>
+      <p:sp>
+        <p:nvSpPr>
+          <p:cNvPr id="39" name="TextBox 38"/>
+          <p:cNvSpPr txBox="1"/>
+          <p:nvPr/>
+        </p:nvSpPr>
+        <p:spPr>
+          <a:xfrm>
+            <a:off x="9006840" y="3570440"/>
+            <a:ext cx="2011680" cy="438912"/>
+          </a:xfrm>
+          <a:prstGeom prst="rect">
+            <a:avLst/>
+          </a:prstGeom>
+          <a:noFill/>
+        </p:spPr>
+        <p:txBody>
+          <a:bodyPr wrap="square">
+            <a:spAutoFit/>
+          </a:bodyPr>
+          <a:lstStyle/>
+          <a:p>
+            <a:pPr algn="l"/>
+            <a:r>
+              <a:rPr sz="1300" b="0">
+                <a:solidFill>
+                  <a:srgbClr val="B8C0CC"/>
+                </a:solidFill>
+                <a:latin typeface="Calibri"/>
+              </a:rPr>
+              <a:t>Máxima fidelidad con presupuesto de tiempo</a:t>
+            </a:r>
+          </a:p>
+        </p:txBody>
+      </p:sp>
+      <p:sp>
+        <p:nvSpPr>
+          <p:cNvPr id="40" name="TextBox 39"/>
+          <p:cNvSpPr txBox="1"/>
+          <p:nvPr/>
+        </p:nvSpPr>
+        <p:spPr>
+          <a:xfrm>
+            <a:off x="548640" y="6263640"/>
+            <a:ext cx="10972800" cy="365760"/>
+          </a:xfrm>
+          <a:prstGeom prst="rect">
+            <a:avLst/>
+          </a:prstGeom>
+          <a:noFill/>
+        </p:spPr>
+        <p:txBody>
+          <a:bodyPr wrap="square">
+            <a:spAutoFit/>
+          </a:bodyPr>
+          <a:lstStyle/>
+          <a:p>
+            <a:pPr algn="l"/>
+            <a:r>
+              <a:rPr sz="1200" b="0">
+                <a:solidFill>
+                  <a:srgbClr val="606878"/>
+                </a:solidFill>
+                <a:latin typeface="Calibri"/>
+              </a:rPr>
+              <a:t>ℹ  Regla práctica: mirar el percentil 90 de posts/usuario. Si P90 &lt; 50 → C=D=E (no hay suficientes posts). Si P90 &gt; 100 → D es el punto óptimo.</a:t>
             </a:r>
           </a:p>
         </p:txBody>
@@ -7016,7 +8652,7 @@
                 </a:solidFill>
                 <a:latin typeface="Calibri"/>
               </a:rPr>
-              <a:t>La regla es simple: datos sensibles → modelo local</a:t>
+              <a:t>¿Cuándo NO usar D?</a:t>
             </a:r>
           </a:p>
         </p:txBody>
@@ -7051,7 +8687,7 @@
                 </a:solidFill>
                 <a:latin typeface="Calibri"/>
               </a:rPr>
-              <a:t>▸  Nunca se mandan leaks a APIs externas — ni OpenAI, ni Anthropic, ni Google</a:t>
+              <a:t>▸  Usuarios con pocos posts: si el 90% tiene menos de 50 posts → C, D y E dan el mismo resultado</a:t>
             </a:r>
           </a:p>
           <a:p>
@@ -7063,7 +8699,7 @@
                 </a:solidFill>
                 <a:latin typeface="Calibri"/>
               </a:rPr>
-              <a:t>▸  Ollama: corre modelos cuantizados (Q4/Q8) en hardware modesto sin salida de datos</a:t>
+              <a:t>▸  Dataset muy grande (&gt;50K usuarios): C puede ser suficiente para reducir coste de GPU a la mitad</a:t>
             </a:r>
           </a:p>
           <a:p>
@@ -7075,7 +8711,7 @@
                 </a:solidFill>
                 <a:latin typeface="Calibri"/>
               </a:rPr>
-              <a:t>▸  qwen2.5:14b con Q4 → 16GB RAM, respuestas en segundos, sin nube</a:t>
+              <a:t>▸  Exploración rápida: A (concat truncado) es el más rápido y sin muestreo — bueno para iterar</a:t>
             </a:r>
           </a:p>
           <a:p>
@@ -7087,7 +8723,7 @@
                 </a:solidFill>
                 <a:latin typeface="Calibri"/>
               </a:rPr>
-              <a:t>▸  El tradeoff: latencia local vs. riesgo de fuga de datos de personas reales</a:t>
+              <a:t>▸  Corpus muy corto por usuario (tweets, mensajes de chat): A es mejor porque hay poco que muestrear</a:t>
             </a:r>
           </a:p>
           <a:p>
@@ -7099,7 +8735,7 @@
                 </a:solidFill>
                 <a:latin typeface="Calibri"/>
               </a:rPr>
-              <a:t>▸  Con datos underground, el riesgo supera siempre al coste de latencia</a:t>
+              <a:t>▸  Regla: siempre revisar la distribución de posts/usuario ANTES de elegir estrategia (notebook 00)</a:t>
             </a:r>
           </a:p>
         </p:txBody>

</xml_diff>